<commit_message>
S1-CL2: realign all delivery decks to the AT1/AT2 workbooks; merge topics 7-8 (one build, one deck)
Co-Authored-By: Claude Fable 5 <noreply@anthropic.com>
</commit_message>
<xml_diff>
--- a/S1-CL2-Cloud-Disaster-Recovery/delivery/topic_05/Topic_05_Slides.pptx
+++ b/S1-CL2-Cloud-Disaster-Recovery/delivery/topic_05/Topic_05_Slides.pptx
@@ -21,6 +21,9 @@
     <p:sldId id="269" r:id="rId21"/>
     <p:sldId id="270" r:id="rId22"/>
     <p:sldId id="271" r:id="rId23"/>
+    <p:sldId id="272" r:id="rId24"/>
+    <p:sldId id="273" r:id="rId25"/>
+    <p:sldId id="274" r:id="rId26"/>
   </p:sldIdLst>
   <p:sldSz cx="12191695" cy="6858000" type="screen4x3"/>
   <p:notesSz cx="6858000" cy="9144000"/>
@@ -517,77 +520,12 @@
           <a:lstStyle/>
           <a:p>
             <a:r>
-              <a:t>Frame Topic 5 as the CLOSE-OUT of AT1 — the design work is done; today it becomes an approved</a:t>
-            </a:r>
-          </a:p>
-          <a:p>
-            <a:r>
-              <a:t>deliverable. Set the mode; don't teach documentation technique yet.</a:t>
-            </a:r>
-          </a:p>
-          <a:p>
-            <a:r>
-              <a:t>• First bullet: Topics 1–4 produced the web-scale design, the microservice design and the DR plan.</a:t>
-            </a:r>
-          </a:p>
-          <a:p>
-            <a:r>
-              <a:t>Today you don't design anything new — you turn that work into finished, signed-off documents.</a:t>
-            </a:r>
-          </a:p>
-          <a:p>
-            <a:r>
-              <a:t>• Second bullet: two moves only — DOCUMENT and justify the Solution Design, then PRESENT both</a:t>
-            </a:r>
-          </a:p>
-          <a:p>
-            <a:r>
-              <a:t>deliverables for approval. Name them; they're C1 and C2 of today.</a:t>
-            </a:r>
-          </a:p>
-          <a:p>
-            <a:r>
-              <a:t>• Third bullet (the gate): approval is a real gate — AT2 implementation does not start until the</a:t>
-            </a:r>
-          </a:p>
-          <a:p>
-            <a:r>
-              <a:t>design is signed off. Nothing gets built on an unapproved design.</a:t>
-            </a:r>
-          </a:p>
-          <a:p>
-            <a:r>
-              <a:t>• Fourth bullet: no new design, no build here — assemble, present, sign off.</a:t>
-            </a:r>
-          </a:p>
-          <a:p>
-            <a:r>
-              <a:t>Misconception to pre-empt: "we're nearly at the build, let's start tweaking the design." No — today</a:t>
-            </a:r>
-          </a:p>
-          <a:p>
-            <a:r>
-              <a:t>is producing and presenting the EXISTING design; changing it now reopens work you've already closed.</a:t>
-            </a:r>
-          </a:p>
-          <a:p>
-            <a:r>
-              <a:t>Question to pose: "Why would an organisation refuse to let you build before the design is signed off?"</a:t>
-            </a:r>
-          </a:p>
-          <a:p>
-            <a:r>
-              <a:t>(accountability + a documented decision to build against — the sign-off is the authority to proceed).</a:t>
-            </a:r>
-          </a:p>
-          <a:p>
-            <a:r>
-              <a:t>UoC/AT1 tie: opens the AT1 close-out — ICTCLD503 (document &amp; justify the design) + ICTCLD501 element 5</a:t>
-            </a:r>
-          </a:p>
-          <a:p>
-            <a:r>
-              <a:t>(present, lodge, sign off); the output is AT1 Part A documentation + Part C presentation.</a:t>
+              <a:t>The performance topic — workbook tasks 38 to 43, run in order, with the Topics 1–4 documents on the desk.</a:t>
+            </a:r>
+          </a:p>
+          <a:p>
+            <a:r>
+              <a:t>The walkthrough is played live (teacher or classmate as the client); set that expectation now.</a:t>
             </a:r>
           </a:p>
         </p:txBody>
@@ -657,82 +595,87 @@
           <a:lstStyle/>
           <a:p>
             <a:r>
-              <a:t>Facilitation — the C3 practice; students complete the formal close-out on the practice scenario: lodge</a:t>
-            </a:r>
-          </a:p>
-          <a:p>
-            <a:r>
-              <a:t>the DR plan and record the sign-off. Short and procedural.</a:t>
-            </a:r>
-          </a:p>
-          <a:p>
-            <a:r>
-              <a:t>Tell students, in these words: "For the practice scenario, lodge the DR plan per protocol, then obtain</a:t>
-            </a:r>
-          </a:p>
-          <a:p>
-            <a:r>
-              <a:t>and record the final sign-off."</a:t>
-            </a:r>
-          </a:p>
-          <a:p>
-            <a:r>
-              <a:t>Steps (put on the board):</a:t>
-            </a:r>
-          </a:p>
-          <a:p>
-            <a:r>
-              <a:t>1. Identify the correct lodgement location/record per the scenario's organisational + legislative</a:t>
-            </a:r>
-          </a:p>
-          <a:p>
-            <a:r>
-              <a:t>protocol, and lodge the DR plan there.</a:t>
-            </a:r>
-          </a:p>
-          <a:p>
-            <a:r>
-              <a:t>2. Obtain final sign-off from the required personnel (role-play the approver).</a:t>
-            </a:r>
-          </a:p>
-          <a:p>
-            <a:r>
-              <a:t>3. RECORD the sign-off — who, what, when — so there's a trail.</a:t>
-            </a:r>
-          </a:p>
-          <a:p>
-            <a:r>
-              <a:t>Must produce: the DR plan lodged in the right place + a recorded sign-off entry (approver, date, what</a:t>
-            </a:r>
-          </a:p>
-          <a:p>
-            <a:r>
-              <a:t>was approved).</a:t>
-            </a:r>
-          </a:p>
-          <a:p>
-            <a:r>
-              <a:t>Timing: ~15 min. Where they get stuck: they treat sign-off as informal ("she said ok") — insist on a</a:t>
-            </a:r>
-          </a:p>
-          <a:p>
-            <a:r>
-              <a:t>recorded acceptance; and they're unsure WHERE to lodge — point them at the scenario's protocol.</a:t>
-            </a:r>
-          </a:p>
-          <a:p>
-            <a:r>
-              <a:t>Share-back prompt: "What exactly did you record as evidence of sign-off, and who could rely on it later?"</a:t>
-            </a:r>
-          </a:p>
-          <a:p>
-            <a:r>
-              <a:t>No-leakage note: practice scenario — AT1 Part C assesses the same lodgement/sign-off on the LMS</a:t>
-            </a:r>
-          </a:p>
-          <a:p>
-            <a:r>
-              <a:t>engagement (comparable, not identical).</a:t>
+              <a:t>Workbook task 43. Conditions are the realistic outcome worth normalising — the workbook says so explicitly.</a:t>
+            </a:r>
+          </a:p>
+          <a:p>
+            <a:r>
+              <a:t>The recorded decision, not the handshake, is what the assessor reads.</a:t>
+            </a:r>
+          </a:p>
+        </p:txBody>
+      </p:sp>
+      <p:sp>
+        <p:nvSpPr>
+          <p:cNvPr id="4" name="Slide Number Placeholder 3"/>
+          <p:cNvSpPr>
+            <a:spLocks noGrp="1"/>
+          </p:cNvSpPr>
+          <p:nvPr>
+            <p:ph type="sldNum" idx="5" sz="quarter"/>
+          </p:nvPr>
+        </p:nvSpPr>
+        <p:spPr/>
+      </p:sp>
+    </p:spTree>
+  </p:cSld>
+  <p:clrMapOvr>
+    <a:masterClrMapping/>
+  </p:clrMapOvr>
+</p:notes>
+</file>
+
+<file path=ppt/notesSlides/notesSlide11.xml><?xml version="1.0" encoding="utf-8"?>
+<p:notes xmlns:a="http://schemas.openxmlformats.org/drawingml/2006/main" xmlns:p="http://schemas.openxmlformats.org/presentationml/2006/main" xmlns:r="http://schemas.openxmlformats.org/officeDocument/2006/relationships">
+  <p:cSld>
+    <p:spTree>
+      <p:nvGrpSpPr>
+        <p:cNvPr id="1" name=""/>
+        <p:cNvGrpSpPr/>
+        <p:nvPr/>
+      </p:nvGrpSpPr>
+      <p:grpSpPr>
+        <a:xfrm>
+          <a:off x="0" y="0"/>
+          <a:ext cx="0" cy="0"/>
+          <a:chOff x="0" y="0"/>
+          <a:chExt cx="0" cy="0"/>
+        </a:xfrm>
+      </p:grpSpPr>
+      <p:sp>
+        <p:nvSpPr>
+          <p:cNvPr id="2" name="Slide Image Placeholder 1"/>
+          <p:cNvSpPr>
+            <a:spLocks noGrp="1"/>
+          </p:cNvSpPr>
+          <p:nvPr>
+            <p:ph type="sldImg" idx="2"/>
+          </p:nvPr>
+        </p:nvSpPr>
+        <p:spPr/>
+      </p:sp>
+      <p:sp>
+        <p:nvSpPr>
+          <p:cNvPr id="3" name="Notes Placeholder 2"/>
+          <p:cNvSpPr>
+            <a:spLocks noGrp="1"/>
+          </p:cNvSpPr>
+          <p:nvPr>
+            <p:ph type="body" idx="3" sz="quarter"/>
+          </p:nvPr>
+        </p:nvSpPr>
+        <p:spPr/>
+        <p:txBody>
+          <a:bodyPr/>
+          <a:lstStyle/>
+          <a:p>
+            <a:r>
+              <a:t>Activity = practice workbook tasks 42–43.</a:t>
+            </a:r>
+          </a:p>
+          <a:p>
+            <a:r>
+              <a:t>Make them cite the policy by name in the lodgement record.</a:t>
             </a:r>
           </a:p>
         </p:txBody>
@@ -802,67 +745,12 @@
           <a:lstStyle/>
           <a:p>
             <a:r>
-              <a:t>A vendor-neutral primer — what it means to write a professional design DOCUMENT, not working notes.</a:t>
-            </a:r>
-          </a:p>
-          <a:p>
-            <a:r>
-              <a:t>Keep it short; it sets the standard before the two bespoke slides apply it.</a:t>
-            </a:r>
-          </a:p>
-          <a:p>
-            <a:r>
-              <a:t>• First bullet: a Solution Design is a professional document — complete, consistent, and readable by</a:t>
-            </a:r>
-          </a:p>
-          <a:p>
-            <a:r>
-              <a:t>someone who wasn't in the room. The test is: could a non-author act on it?</a:t>
-            </a:r>
-          </a:p>
-          <a:p>
-            <a:r>
-              <a:t>• Second bullet: writing TO the YAT template makes structure and quality predictable — the reader</a:t>
-            </a:r>
-          </a:p>
-          <a:p>
-            <a:r>
-              <a:t>knows where to find each thing, and you can't forget a section.</a:t>
-            </a:r>
-          </a:p>
-          <a:p>
-            <a:r>
-              <a:t>• Third bullet: plain professional English — precise, no jargon for its own sake. Clear beats clever.</a:t>
-            </a:r>
-          </a:p>
-          <a:p>
-            <a:r>
-              <a:t>Misconception to pre-empt: "the design work is done, so writing it up is just formatting." No — the</a:t>
-            </a:r>
-          </a:p>
-          <a:p>
-            <a:r>
-              <a:t>document IS the deliverable the client approves; a strong design described badly fails the same as a</a:t>
-            </a:r>
-          </a:p>
-          <a:p>
-            <a:r>
-              <a:t>weak one.</a:t>
-            </a:r>
-          </a:p>
-          <a:p>
-            <a:r>
-              <a:t>Question to pose: "If your reader is a manager who wasn't in your design sessions, what must the</a:t>
-            </a:r>
-          </a:p>
-          <a:p>
-            <a:r>
-              <a:t>document do that your notes don't?" (stand alone — explain itself without you there).</a:t>
-            </a:r>
-          </a:p>
-          <a:p>
-            <a:r>
-              <a:t>UoC/AT1 tie: sets up ICTCLD503 PC 1.7 / PC 2.4 (document &amp; justify) → AT1 Part A quality (criterion A13).</a:t>
+              <a:t>Purpose is approval, not information — managers approve decisions, so present decisions.</a:t>
+            </a:r>
+          </a:p>
+          <a:p>
+            <a:r>
+              <a:t>Question to pose: fifteen minutes, thirty pages — what do you actually talk about?</a:t>
             </a:r>
           </a:p>
         </p:txBody>
@@ -932,67 +820,12 @@
           <a:lstStyle/>
           <a:p>
             <a:r>
-              <a:t>Bespoke — the assembly job: two separate design strands become ONE coherent Solution Design.</a:t>
-            </a:r>
-          </a:p>
-          <a:p>
-            <a:r>
-              <a:t>• First bullet: bring together the web-scale architecture (Topic 1) and the microservice design</a:t>
-            </a:r>
-          </a:p>
-          <a:p>
-            <a:r>
-              <a:t>(Topic 2) into a single document — one artefact the client reads, not two loose pieces.</a:t>
-            </a:r>
-          </a:p>
-          <a:p>
-            <a:r>
-              <a:t>• Second bullet: each section maps to a requirement — a reader can trace a design choice back to the</a:t>
-            </a:r>
-          </a:p>
-          <a:p>
-            <a:r>
-              <a:t>need that drove it. Traceability is what makes it a design, not a description.</a:t>
-            </a:r>
-          </a:p>
-          <a:p>
-            <a:r>
-              <a:t>• Third bullet: internal consistency — the diagrams, tables and prose must AGREE. A diagram that shows</a:t>
-            </a:r>
-          </a:p>
-          <a:p>
-            <a:r>
-              <a:t>three tiers and prose that describes two is an instant credibility loss.</a:t>
-            </a:r>
-          </a:p>
-          <a:p>
-            <a:r>
-              <a:t>Misconception to pre-empt: "assemble = staple the two designs together." No — you integrate them into</a:t>
-            </a:r>
-          </a:p>
-          <a:p>
-            <a:r>
-              <a:t>one narrative with consistent terminology, numbering and diagrams; contradictions between the halves</a:t>
-            </a:r>
-          </a:p>
-          <a:p>
-            <a:r>
-              <a:t>are the commonest fault.</a:t>
-            </a:r>
-          </a:p>
-          <a:p>
-            <a:r>
-              <a:t>Question to pose: "If a reader picks any design choice in your document, what should they be able to</a:t>
-            </a:r>
-          </a:p>
-          <a:p>
-            <a:r>
-              <a:t>find nearby?" (the requirement it satisfies — the trace).</a:t>
-            </a:r>
-          </a:p>
-          <a:p>
-            <a:r>
-              <a:t>UoC/AT1 tie: ICTCLD503 PC 2.4 (document the architecture design) → AT1 Part A (criterion A11).</a:t>
+              <a:t>Workbook task 38 — the walkthrough plan. One point per part is the discipline that stops a page-turn.</a:t>
+            </a:r>
+          </a:p>
+          <a:p>
+            <a:r>
+              <a:t>The timing warning comes from the workbook itself; make them rehearse against a clock.</a:t>
             </a:r>
           </a:p>
         </p:txBody>
@@ -1062,77 +895,12 @@
           <a:lstStyle/>
           <a:p>
             <a:r>
-              <a:t>Bespoke — the JUSTIFICATION discipline, the heart of C1. Teach that a design without reasons is just</a:t>
-            </a:r>
-          </a:p>
-          <a:p>
-            <a:r>
-              <a:t>an assertion.</a:t>
-            </a:r>
-          </a:p>
-          <a:p>
-            <a:r>
-              <a:t>• First bullet: document AND justify both the architecture CHANGES (web-scale) and the microservice</a:t>
-            </a:r>
-          </a:p>
-          <a:p>
-            <a:r>
-              <a:t>design. Two things get justified, not one.</a:t>
-            </a:r>
-          </a:p>
-          <a:p>
-            <a:r>
-              <a:t>• Second bullet: the shape of a justification — the requirement met, the option you chose, and WHY over</a:t>
-            </a:r>
-          </a:p>
-          <a:p>
-            <a:r>
-              <a:t>the alternatives. Say all three; a choice with no rejected alternative isn't justified.</a:t>
-            </a:r>
-          </a:p>
-          <a:p>
-            <a:r>
-              <a:t>• Third bullet (the line that matters): unjustified design is an opinion; justified design is defensible</a:t>
-            </a:r>
-          </a:p>
-          <a:p>
-            <a:r>
-              <a:t>under Q&amp;A — and Q&amp;A is exactly what happens in the walkthrough next.</a:t>
-            </a:r>
-          </a:p>
-          <a:p>
-            <a:r>
-              <a:t>Misconception to pre-empt: "justify = describe what I built." No — describing is C1's assembly;</a:t>
-            </a:r>
-          </a:p>
-          <a:p>
-            <a:r>
-              <a:t>justifying is arguing why THIS over the options. Students routinely restate the design and call it</a:t>
-            </a:r>
-          </a:p>
-          <a:p>
-            <a:r>
-              <a:t>justification.</a:t>
-            </a:r>
-          </a:p>
-          <a:p>
-            <a:r>
-              <a:t>Question to pose: "You chose a managed database over self-managed on EC2 — what three things must your</a:t>
-            </a:r>
-          </a:p>
-          <a:p>
-            <a:r>
-              <a:t>justification state?" (the requirement, the option chosen, why over the alternative).</a:t>
-            </a:r>
-          </a:p>
-          <a:p>
-            <a:r>
-              <a:t>UoC/AT1 tie: ICTCLD503 PC 1.7 (document &amp; justify changes) + PC 2.4 → AT1 Part A criteria A11/A13; the</a:t>
-            </a:r>
-          </a:p>
-          <a:p>
-            <a:r>
-              <a:t>justification is what the Part C Q&amp;A tests.</a:t>
+              <a:t>Workbook task 39. The challengeable choices are the ones with a rejected alternative — that's where questions land.</a:t>
+            </a:r>
+          </a:p>
+          <a:p>
+            <a:r>
+              <a:t>Connects straight back to the justification tasks in Parts A and B.</a:t>
             </a:r>
           </a:p>
         </p:txBody>
@@ -1202,82 +970,12 @@
           <a:lstStyle/>
           <a:p>
             <a:r>
-              <a:t>Facilitation — the C1 practice; students assemble and justify the PRACTICE scenario's Solution Design</a:t>
-            </a:r>
-          </a:p>
-          <a:p>
-            <a:r>
-              <a:t>in the YAT template. Mirrors AT1 Part A on a different engagement.</a:t>
-            </a:r>
-          </a:p>
-          <a:p>
-            <a:r>
-              <a:t>Tell students, in these words: "For the practice scenario, assemble the Solution Design in the YAT</a:t>
-            </a:r>
-          </a:p>
-          <a:p>
-            <a:r>
-              <a:t>template — bring the web-scale and microservice designs into one document — and document and justify</a:t>
-            </a:r>
-          </a:p>
-          <a:p>
-            <a:r>
-              <a:t>the architecture changes and the microservice design."</a:t>
-            </a:r>
-          </a:p>
-          <a:p>
-            <a:r>
-              <a:t>Steps (put on the board):</a:t>
-            </a:r>
-          </a:p>
-          <a:p>
-            <a:r>
-              <a:t>1. Open the YAT Solution Design template and drop the two design strands into their sections.</a:t>
-            </a:r>
-          </a:p>
-          <a:p>
-            <a:r>
-              <a:t>2. For each major choice, write the justification: requirement met → option chosen → why over the</a:t>
-            </a:r>
-          </a:p>
-          <a:p>
-            <a:r>
-              <a:t>alternatives.</a:t>
-            </a:r>
-          </a:p>
-          <a:p>
-            <a:r>
-              <a:t>3. Check internal consistency — diagrams, tables and prose agree; each section traces to a requirement.</a:t>
-            </a:r>
-          </a:p>
-          <a:p>
-            <a:r>
-              <a:t>Must produce: an assembled Solution Design (in the template) with each major change/choice justified.</a:t>
-            </a:r>
-          </a:p>
-          <a:p>
-            <a:r>
-              <a:t>Timing: ~30 min. Where they get stuck: they DESCRIBE the design instead of JUSTIFYING it — circulate</a:t>
-            </a:r>
-          </a:p>
-          <a:p>
-            <a:r>
-              <a:t>and ask "why this over the alternative?" at each choice; also watch for the two strands contradicting.</a:t>
-            </a:r>
-          </a:p>
-          <a:p>
-            <a:r>
-              <a:t>Share-back prompt: take one student's justification and ask the room whether it names a rejected option.</a:t>
-            </a:r>
-          </a:p>
-          <a:p>
-            <a:r>
-              <a:t>No-leakage note: this is the PRACTICE scenario — AT1 assesses the same assemble-and-justify skill on the</a:t>
-            </a:r>
-          </a:p>
-          <a:p>
-            <a:r>
-              <a:t>LMS engagement (comparable, not identical); keep them on the practice design here.</a:t>
+              <a:t>Activity = practice workbook tasks 38–39.</a:t>
+            </a:r>
+          </a:p>
+          <a:p>
+            <a:r>
+              <a:t>Press "one point per part" — most first drafts have five.</a:t>
             </a:r>
           </a:p>
         </p:txBody>
@@ -1347,62 +1045,12 @@
           <a:lstStyle/>
           <a:p>
             <a:r>
-              <a:t>A primer on what a design "walkthrough" is — vendor-neutral, before the bespoke how-to.</a:t>
-            </a:r>
-          </a:p>
-          <a:p>
-            <a:r>
-              <a:t>• First bullet: a walkthrough presents the design + DR plan to the required personnel for a DECISION —</a:t>
-            </a:r>
-          </a:p>
-          <a:p>
-            <a:r>
-              <a:t>its purpose is approval, not information.</a:t>
-            </a:r>
-          </a:p>
-          <a:p>
-            <a:r>
-              <a:t>• Second bullet: speak to your CHOICES and their rationale — not every line. Managers approve decisions,</a:t>
-            </a:r>
-          </a:p>
-          <a:p>
-            <a:r>
-              <a:t>so present the decisions that matter, not a page-turn.</a:t>
-            </a:r>
-          </a:p>
-          <a:p>
-            <a:r>
-              <a:t>• Third bullet: approval is a CONVERSATION — they will probe, you will respond. Expect questions; they</a:t>
-            </a:r>
-          </a:p>
-          <a:p>
-            <a:r>
-              <a:t>are the point, not an interruption.</a:t>
-            </a:r>
-          </a:p>
-          <a:p>
-            <a:r>
-              <a:t>Misconception to pre-empt: "a walkthrough is reading the document aloud." No — it's a curated pitch of</a:t>
-            </a:r>
-          </a:p>
-          <a:p>
-            <a:r>
-              <a:t>the key decisions; reading every line loses the room and hides the decisions under detail.</a:t>
-            </a:r>
-          </a:p>
-          <a:p>
-            <a:r>
-              <a:t>Question to pose: "You have 15 minutes with the approvers and a 30-page design — what do you actually</a:t>
-            </a:r>
-          </a:p>
-          <a:p>
-            <a:r>
-              <a:t>talk about?" (the decisions and their rationale, not the whole document).</a:t>
-            </a:r>
-          </a:p>
-          <a:p>
-            <a:r>
-              <a:t>UoC/AT1 tie: ICTCLD501 PC 5.1 (conduct the walkthrough with required personnel) → AT1 Part C (C1/C6).</a:t>
+              <a:t>Workbook task 40 — the live session plus its record. The record is filled in straight after, not reconstructed later.</a:t>
+            </a:r>
+          </a:p>
+          <a:p>
+            <a:r>
+              <a:t>In class the client is played by the teacher or a classmate; both work.</a:t>
             </a:r>
           </a:p>
         </p:txBody>
@@ -1472,77 +1120,12 @@
           <a:lstStyle/>
           <a:p>
             <a:r>
-              <a:t>Bespoke — the two live skills of the walkthrough: presenting your choices and handling feedback in</a:t>
-            </a:r>
-          </a:p>
-          <a:p>
-            <a:r>
-              <a:t>real time.</a:t>
-            </a:r>
-          </a:p>
-          <a:p>
-            <a:r>
-              <a:t>• First bullet: conduct the VERBAL walkthrough of the Solution Design AND the DR Plan with the required</a:t>
-            </a:r>
-          </a:p>
-          <a:p>
-            <a:r>
-              <a:t>personnel — both deliverables, one session.</a:t>
-            </a:r>
-          </a:p>
-          <a:p>
-            <a:r>
-              <a:t>• Second bullet: seek feedback DELIBERATELY, then respond to it — accept it, adjust, or defend with</a:t>
-            </a:r>
-          </a:p>
-          <a:p>
-            <a:r>
-              <a:t>reasons. All three are valid responses; silence isn't.</a:t>
-            </a:r>
-          </a:p>
-          <a:p>
-            <a:r>
-              <a:t>• Third bullet: answer contextual Q&amp;A on your OWN choices — this is where the justification you wrote in</a:t>
-            </a:r>
-          </a:p>
-          <a:p>
-            <a:r>
-              <a:t>C1 pays off. If you justified it, you can defend it.</a:t>
-            </a:r>
-          </a:p>
-          <a:p>
-            <a:r>
-              <a:t>Misconception to pre-empt: "responding to feedback means agreeing to every change." No — a good</a:t>
-            </a:r>
-          </a:p>
-          <a:p>
-            <a:r>
-              <a:t>consultant defends a sound choice with reasons and adjusts where the feedback is right; both are</a:t>
-            </a:r>
-          </a:p>
-          <a:p>
-            <a:r>
-              <a:t>professional. Caving to every comment reads as no conviction.</a:t>
-            </a:r>
-          </a:p>
-          <a:p>
-            <a:r>
-              <a:t>Question to pose: "An approver says 'why not just use one big server?' — what's your move?" (respond</a:t>
-            </a:r>
-          </a:p>
-          <a:p>
-            <a:r>
-              <a:t>with the requirement/justification — defend or adjust, don't freeze).</a:t>
-            </a:r>
-          </a:p>
-          <a:p>
-            <a:r>
-              <a:t>UoC/AT1 tie: ICTCLD501 PC 5.1 + PC 5.2 (conduct walkthrough; seek &amp; respond to feedback) → AT1 Part C</a:t>
-            </a:r>
-          </a:p>
-          <a:p>
-            <a:r>
-              <a:t>(criteria C1, C2, C5); the Q&amp;A tests the KE behind your choices.</a:t>
+              <a:t>Workbook task 41. Whoever plays the client gives at least one thing to change — that's the point of the exercise.</a:t>
+            </a:r>
+          </a:p>
+          <a:p>
+            <a:r>
+              <a:t>Caving to every comment reads as no conviction; defending everything reads as not listening. Either extreme is the coaching moment.</a:t>
             </a:r>
           </a:p>
         </p:txBody>
@@ -1612,77 +1195,12 @@
           <a:lstStyle/>
           <a:p>
             <a:r>
-              <a:t>Facilitation — the C2 practice; students rehearse the walkthrough of the practice design + DR plan, in</a:t>
-            </a:r>
-          </a:p>
-          <a:p>
-            <a:r>
-              <a:t>pairs (presenter + approver). Mirrors AT1 Part C.</a:t>
-            </a:r>
-          </a:p>
-          <a:p>
-            <a:r>
-              <a:t>Tell students, in these words: "For the practice scenario, rehearse the walkthrough of your Solution</a:t>
-            </a:r>
-          </a:p>
-          <a:p>
-            <a:r>
-              <a:t>Design and DR plan. Present your key choices, seek feedback, and answer questions on your decisions."</a:t>
-            </a:r>
-          </a:p>
-          <a:p>
-            <a:r>
-              <a:t>Run it as pairs (swap roles):</a:t>
-            </a:r>
-          </a:p>
-          <a:p>
-            <a:r>
-              <a:t>1. One student presents the design + DR plan to a partner playing the required personnel — decisions,</a:t>
-            </a:r>
-          </a:p>
-          <a:p>
-            <a:r>
-              <a:t>not every line, ~5 min.</a:t>
-            </a:r>
-          </a:p>
-          <a:p>
-            <a:r>
-              <a:t>2. The "approver" probes: asks why each major choice, offers one piece of feedback.</a:t>
-            </a:r>
-          </a:p>
-          <a:p>
-            <a:r>
-              <a:t>3. The presenter responds — accept / adjust / defend with reasons — then swap.</a:t>
-            </a:r>
-          </a:p>
-          <a:p>
-            <a:r>
-              <a:t>Must produce: each student has presented their choices aloud and fielded at least two probing questions.</a:t>
-            </a:r>
-          </a:p>
-          <a:p>
-            <a:r>
-              <a:t>Timing: ~25 min (both roles). Where they get stuck: they narrate the document line by line instead of</a:t>
-            </a:r>
-          </a:p>
-          <a:p>
-            <a:r>
-              <a:t>pitching decisions, and they freeze on pushback — coach them to answer from their C1 justification.</a:t>
-            </a:r>
-          </a:p>
-          <a:p>
-            <a:r>
-              <a:t>Share-back prompt: ask one pair to replay the toughest question and how the presenter handled it.</a:t>
-            </a:r>
-          </a:p>
-          <a:p>
-            <a:r>
-              <a:t>No-leakage note: practice scenario only — AT1 Part C assesses the same presentation skill on the LMS</a:t>
-            </a:r>
-          </a:p>
-          <a:p>
-            <a:r>
-              <a:t>engagement (comparable, not identical).</a:t>
+              <a:t>Activity = practice workbook tasks 40–41, in pairs, both roles.</a:t>
+            </a:r>
+          </a:p>
+          <a:p>
+            <a:r>
+              <a:t>The approver probes the choices and offers at least one change; the presenter answers from their own justifications.</a:t>
             </a:r>
           </a:p>
         </p:txBody>
@@ -1752,82 +1270,12 @@
           <a:lstStyle/>
           <a:p>
             <a:r>
-              <a:t>Bespoke — the formal close: lodging per protocol and obtaining sign-off. Teach these as PROCEDURAL</a:t>
-            </a:r>
-          </a:p>
-          <a:p>
-            <a:r>
-              <a:t>acts with a paper trail, not a handshake.</a:t>
-            </a:r>
-          </a:p>
-          <a:p>
-            <a:r>
-              <a:t>• First bullet: lodge the DR plan per the organisational AND legislative protocol — the right place, the</a:t>
-            </a:r>
-          </a:p>
-          <a:p>
-            <a:r>
-              <a:t>right record. Lodgement is where the approved plan is formally stored/registered, not emailed.</a:t>
-            </a:r>
-          </a:p>
-          <a:p>
-            <a:r>
-              <a:t>• Second bullet: obtain final SIGN-OFF from the required personnel — the formal acceptance that the</a:t>
-            </a:r>
-          </a:p>
-          <a:p>
-            <a:r>
-              <a:t>design is approved.</a:t>
-            </a:r>
-          </a:p>
-          <a:p>
-            <a:r>
-              <a:t>• Third bullet (the gate): sign-off is the gate to AT2 — nothing is built until the design is approved.</a:t>
-            </a:r>
-          </a:p>
-          <a:p>
-            <a:r>
-              <a:t>Callback to the opener.</a:t>
-            </a:r>
-          </a:p>
-          <a:p>
-            <a:r>
-              <a:t>Misconception to pre-empt: "sign-off is just someone saying yes." No — it's a recorded, formal</a:t>
-            </a:r>
-          </a:p>
-          <a:p>
-            <a:r>
-              <a:t>acceptance by the required personnel, lodged per protocol; the record is what authorises the build and</a:t>
-            </a:r>
-          </a:p>
-          <a:p>
-            <a:r>
-              <a:t>what an auditor looks for.</a:t>
-            </a:r>
-          </a:p>
-          <a:p>
-            <a:r>
-              <a:t>Question to pose: "Why does the DR plan have to be lodged 'per organisational and legislative protocol'</a:t>
-            </a:r>
-          </a:p>
-          <a:p>
-            <a:r>
-              <a:t>— why not just save it anywhere?" (compliance/retention + it must be findable by the people who'll rely</a:t>
-            </a:r>
-          </a:p>
-          <a:p>
-            <a:r>
-              <a:t>on it in a real disaster).</a:t>
-            </a:r>
-          </a:p>
-          <a:p>
-            <a:r>
-              <a:t>UoC/AT1 tie: ICTCLD501 PC 5.3 (lodge per protocol) + PC 5.4 (obtain final sign-off) → AT1 Part C</a:t>
-            </a:r>
-          </a:p>
-          <a:p>
-            <a:r>
-              <a:t>(criteria C3, C4).</a:t>
+              <a:t>Workbook task 42 — lodgement per the organisation's Records Management Policy, not to personal preference.</a:t>
+            </a:r>
+          </a:p>
+          <a:p>
+            <a:r>
+              <a:t>The policy is on the intranet; the task is reading it and doing what it says.</a:t>
             </a:r>
           </a:p>
         </p:txBody>
@@ -4930,7 +4378,7 @@
                 </a:solidFill>
                 <a:latin typeface="Roboto"/>
               </a:rPr>
-              <a:t>Documenting &amp; presenting for approval</a:t>
+              <a:t>Presenting for approval</a:t>
             </a:r>
           </a:p>
           <a:p>
@@ -4946,7 +4394,7 @@
                 </a:solidFill>
                 <a:latin typeface="Roboto Light"/>
               </a:rPr>
-              <a:t>Assemble and justify the Solution Design, present both deliverables, and get sign-off</a:t>
+              <a:t>Walk the client through the design and plan, respond to feedback, lodge and get sign-off</a:t>
             </a:r>
           </a:p>
         </p:txBody>
@@ -5049,7 +4497,7 @@
                 </a:solidFill>
                 <a:latin typeface="Roboto"/>
               </a:rPr>
-              <a:t>Conduct the walkthrough &amp; handle feedback</a:t>
+              <a:t>Conduct the walkthrough</a:t>
             </a:r>
           </a:p>
         </p:txBody>
@@ -5147,7 +4595,7 @@
                 </a:solidFill>
                 <a:latin typeface="Roboto"/>
               </a:rPr>
-              <a:t>Conduct the verbal walkthrough of the Solution Design and DR Plan with the required personnel.</a:t>
+              <a:t>Present the design and plan to the client, to your plan, inside the time.</a:t>
             </a:r>
           </a:p>
           <a:p>
@@ -5178,7 +4626,7 @@
                 </a:solidFill>
                 <a:latin typeface="Roboto"/>
               </a:rPr>
-              <a:t>Seek feedback deliberately, and respond to it — accept, adjust, or defend with reasons.</a:t>
+              <a:t>Record the session immediately afterwards: when, who, and what was actually covered.</a:t>
             </a:r>
           </a:p>
           <a:p>
@@ -5209,7 +4657,7 @@
                 </a:solidFill>
                 <a:latin typeface="Roboto"/>
               </a:rPr>
-              <a:t>Answer contextual Q&amp;A on your own choices — this is where the justification pays off.</a:t>
+              <a:t>The record is evidence of the performance — written while you still remember it.</a:t>
             </a:r>
           </a:p>
         </p:txBody>
@@ -5364,14 +4812,48 @@
       <p:grpSpPr/>
       <p:sp>
         <p:nvSpPr>
-          <p:cNvPr id="2" name="Rectangle 1"/>
+          <p:cNvPr id="2" name="TextBox 1"/>
+          <p:cNvSpPr txBox="1"/>
+          <p:nvPr/>
+        </p:nvSpPr>
+        <p:spPr>
+          <a:xfrm>
+            <a:off x="640080" y="457200"/>
+            <a:ext cx="10881360" cy="960120"/>
+          </a:xfrm>
+          <a:prstGeom prst="rect">
+            <a:avLst/>
+          </a:prstGeom>
+          <a:noFill/>
+        </p:spPr>
+        <p:txBody>
+          <a:bodyPr wrap="square" anchor="t" lIns="0" rIns="0" tIns="0" bIns="0">
+            <a:spAutoFit/>
+          </a:bodyPr>
+          <a:lstStyle/>
+          <a:p>
+            <a:r>
+              <a:rPr sz="2800" b="1" i="0">
+                <a:solidFill>
+                  <a:srgbClr val="2A2929"/>
+                </a:solidFill>
+                <a:latin typeface="Roboto"/>
+              </a:rPr>
+              <a:t>Seek feedback, and respond to it</a:t>
+            </a:r>
+          </a:p>
+        </p:txBody>
+      </p:sp>
+      <p:sp>
+        <p:nvSpPr>
+          <p:cNvPr id="3" name="Rectangle 2"/>
           <p:cNvSpPr/>
           <p:nvPr/>
         </p:nvSpPr>
         <p:spPr>
           <a:xfrm>
-            <a:off x="0" y="0"/>
-            <a:ext cx="12191695" cy="1234440"/>
+            <a:off x="658368" y="1371600"/>
+            <a:ext cx="1463040" cy="50800"/>
           </a:xfrm>
           <a:prstGeom prst="rect">
             <a:avLst/>
@@ -5408,67 +4890,14 @@
       </p:sp>
       <p:sp>
         <p:nvSpPr>
-          <p:cNvPr id="3" name="Rounded Rectangle 2"/>
-          <p:cNvSpPr/>
-          <p:nvPr/>
-        </p:nvSpPr>
-        <p:spPr>
-          <a:xfrm>
-            <a:off x="640080" y="384048"/>
-            <a:ext cx="1691640" cy="457200"/>
-          </a:xfrm>
-          <a:prstGeom prst="roundRect">
-            <a:avLst/>
-          </a:prstGeom>
-          <a:solidFill>
-            <a:srgbClr val="2A2929"/>
-          </a:solidFill>
-          <a:ln>
-            <a:noFill/>
-          </a:ln>
-          <a:effectLst/>
-        </p:spPr>
-        <p:style>
-          <a:lnRef idx="1">
-            <a:schemeClr val="accent1"/>
-          </a:lnRef>
-          <a:fillRef idx="3">
-            <a:schemeClr val="accent1"/>
-          </a:fillRef>
-          <a:effectRef idx="2">
-            <a:schemeClr val="accent1"/>
-          </a:effectRef>
-          <a:fontRef idx="minor">
-            <a:schemeClr val="lt1"/>
-          </a:fontRef>
-        </p:style>
-        <p:txBody>
-          <a:bodyPr rtlCol="0" anchor="ctr"/>
-          <a:lstStyle/>
-          <a:p>
-            <a:pPr algn="ctr"/>
-            <a:r>
-              <a:rPr sz="1400" b="1" i="0">
-                <a:solidFill>
-                  <a:srgbClr val="FBB900"/>
-                </a:solidFill>
-                <a:latin typeface="Roboto"/>
-              </a:rPr>
-              <a:t>ACTIVITY</a:t>
-            </a:r>
-          </a:p>
-        </p:txBody>
-      </p:sp>
-      <p:sp>
-        <p:nvSpPr>
           <p:cNvPr id="4" name="TextBox 3"/>
           <p:cNvSpPr txBox="1"/>
           <p:nvPr/>
         </p:nvSpPr>
         <p:spPr>
           <a:xfrm>
-            <a:off x="2560320" y="310896"/>
-            <a:ext cx="8961120" cy="685800"/>
+            <a:off x="658368" y="1691640"/>
+            <a:ext cx="10881360" cy="4480560"/>
           </a:xfrm>
           <a:prstGeom prst="rect">
             <a:avLst/>
@@ -5477,40 +4906,6 @@
         </p:spPr>
         <p:txBody>
           <a:bodyPr wrap="square" anchor="ctr" lIns="0" rIns="0" tIns="0" bIns="0">
-            <a:spAutoFit/>
-          </a:bodyPr>
-          <a:lstStyle/>
-          <a:p>
-            <a:r>
-              <a:rPr sz="2600" b="1" i="0">
-                <a:solidFill>
-                  <a:srgbClr val="FFFFFF"/>
-                </a:solidFill>
-                <a:latin typeface="Roboto"/>
-              </a:rPr>
-              <a:t>Rehearse the walkthrough</a:t>
-            </a:r>
-          </a:p>
-        </p:txBody>
-      </p:sp>
-      <p:sp>
-        <p:nvSpPr>
-          <p:cNvPr id="5" name="TextBox 4"/>
-          <p:cNvSpPr txBox="1"/>
-          <p:nvPr/>
-        </p:nvSpPr>
-        <p:spPr>
-          <a:xfrm>
-            <a:off x="658368" y="1554480"/>
-            <a:ext cx="10881360" cy="4297680"/>
-          </a:xfrm>
-          <a:prstGeom prst="rect">
-            <a:avLst/>
-          </a:prstGeom>
-          <a:noFill/>
-        </p:spPr>
-        <p:txBody>
-          <a:bodyPr wrap="square" anchor="t" lIns="0" rIns="0" tIns="0" bIns="0">
             <a:spAutoFit/>
           </a:bodyPr>
           <a:lstStyle/>
@@ -5527,7 +4922,7 @@
               </a:spcAft>
             </a:pPr>
             <a:r>
-              <a:rPr sz="1700" b="1" i="0">
+              <a:rPr sz="2400" b="1" i="0">
                 <a:solidFill>
                   <a:srgbClr val="EDAB0C"/>
                 </a:solidFill>
@@ -5536,13 +4931,13 @@
               <a:t>■  </a:t>
             </a:r>
             <a:r>
-              <a:rPr sz="1700" b="0" i="0">
+              <a:rPr sz="2400" b="0" i="0">
                 <a:solidFill>
                   <a:srgbClr val="2A2929"/>
                 </a:solidFill>
                 <a:latin typeface="Roboto"/>
               </a:rPr>
-              <a:t>For the practice scenario, rehearse the walkthrough of the design + DR plan.</a:t>
+              <a:t>Ask for feedback deliberately — don't wait for it to be offered.</a:t>
             </a:r>
           </a:p>
           <a:p>
@@ -5558,7 +4953,7 @@
               </a:spcAft>
             </a:pPr>
             <a:r>
-              <a:rPr sz="1700" b="1" i="0">
+              <a:rPr sz="2400" b="1" i="0">
                 <a:solidFill>
                   <a:srgbClr val="EDAB0C"/>
                 </a:solidFill>
@@ -5567,100 +4962,51 @@
               <a:t>■  </a:t>
             </a:r>
             <a:r>
-              <a:rPr sz="1700" b="0" i="0">
+              <a:rPr sz="2400" b="0" i="0">
                 <a:solidFill>
                   <a:srgbClr val="2A2929"/>
                 </a:solidFill>
                 <a:latin typeface="Roboto"/>
               </a:rPr>
-              <a:t>Seek and respond to feedback; answer Q&amp;A on your choices.</a:t>
-            </a:r>
-          </a:p>
-        </p:txBody>
-      </p:sp>
-      <p:sp>
-        <p:nvSpPr>
-          <p:cNvPr id="6" name="Rounded Rectangle 5"/>
-          <p:cNvSpPr/>
-          <p:nvPr/>
-        </p:nvSpPr>
-        <p:spPr>
-          <a:xfrm>
-            <a:off x="640080" y="5897880"/>
-            <a:ext cx="4023360" cy="457200"/>
-          </a:xfrm>
-          <a:prstGeom prst="roundRect">
-            <a:avLst/>
-          </a:prstGeom>
-          <a:solidFill>
-            <a:srgbClr val="F9F9F9"/>
-          </a:solidFill>
-          <a:ln w="12700">
-            <a:solidFill>
-              <a:srgbClr val="CCCCCC"/>
-            </a:solidFill>
-          </a:ln>
-          <a:effectLst/>
-        </p:spPr>
-        <p:style>
-          <a:lnRef idx="1">
-            <a:schemeClr val="accent1"/>
-          </a:lnRef>
-          <a:fillRef idx="3">
-            <a:schemeClr val="accent1"/>
-          </a:fillRef>
-          <a:effectRef idx="2">
-            <a:schemeClr val="accent1"/>
-          </a:effectRef>
-          <a:fontRef idx="minor">
-            <a:schemeClr val="lt1"/>
-          </a:fontRef>
-        </p:style>
-        <p:txBody>
-          <a:bodyPr rtlCol="0" anchor="ctr"/>
-          <a:lstStyle/>
-          <a:p>
-            <a:pPr algn="ctr"/>
-          </a:p>
-        </p:txBody>
-      </p:sp>
-      <p:sp>
-        <p:nvSpPr>
-          <p:cNvPr id="7" name="TextBox 6"/>
-          <p:cNvSpPr txBox="1"/>
-          <p:nvPr/>
-        </p:nvSpPr>
-        <p:spPr>
-          <a:xfrm>
-            <a:off x="822960" y="5943600"/>
-            <a:ext cx="3657600" cy="365760"/>
-          </a:xfrm>
-          <a:prstGeom prst="rect">
-            <a:avLst/>
-          </a:prstGeom>
-          <a:noFill/>
-        </p:spPr>
-        <p:txBody>
-          <a:bodyPr wrap="square" anchor="ctr" lIns="0" rIns="0" tIns="0" bIns="0">
-            <a:spAutoFit/>
-          </a:bodyPr>
-          <a:lstStyle/>
-          <a:p>
-            <a:r>
-              <a:rPr sz="1500" b="1" i="0">
+              <a:t>Respond: accept and adjust, or defend with reasons. Both are professional; silence is neither.</a:t>
+            </a:r>
+          </a:p>
+          <a:p>
+            <a:pPr marL="0" indent="0">
+              <a:lnSpc>
+                <a:spcPct val="105000"/>
+              </a:lnSpc>
+              <a:spcBef>
+                <a:spcPts val="0"/>
+              </a:spcBef>
+              <a:spcAft>
+                <a:spcPts val="1000"/>
+              </a:spcAft>
+            </a:pPr>
+            <a:r>
+              <a:rPr sz="2400" b="1" i="0">
+                <a:solidFill>
+                  <a:srgbClr val="EDAB0C"/>
+                </a:solidFill>
+                <a:latin typeface="Roboto"/>
+              </a:rPr>
+              <a:t>■  </a:t>
+            </a:r>
+            <a:r>
+              <a:rPr sz="2400" b="0" i="0">
                 <a:solidFill>
                   <a:srgbClr val="2A2929"/>
                 </a:solidFill>
                 <a:latin typeface="Roboto"/>
               </a:rPr>
-              <a:t>⏱  ~25 min</a:t>
-            </a:r>
-          </a:p>
-        </p:txBody>
-      </p:sp>
-      <p:sp>
-        <p:nvSpPr>
-          <p:cNvPr id="8" name="Rectangle 7"/>
+              <a:t>Record what was said and what you did about it.</a:t>
+            </a:r>
+          </a:p>
+        </p:txBody>
+      </p:sp>
+      <p:sp>
+        <p:nvSpPr>
+          <p:cNvPr id="5" name="Rectangle 4"/>
           <p:cNvSpPr/>
           <p:nvPr/>
         </p:nvSpPr>
@@ -5704,7 +5050,7 @@
       </p:sp>
       <p:sp>
         <p:nvSpPr>
-          <p:cNvPr id="9" name="TextBox 8"/>
+          <p:cNvPr id="6" name="TextBox 5"/>
           <p:cNvSpPr txBox="1"/>
           <p:nvPr/>
         </p:nvSpPr>
@@ -5747,7 +5093,7 @@
       </p:sp>
       <p:sp>
         <p:nvSpPr>
-          <p:cNvPr id="10" name="TextBox 9"/>
+          <p:cNvPr id="7" name="TextBox 6"/>
           <p:cNvSpPr txBox="1"/>
           <p:nvPr/>
         </p:nvSpPr>
@@ -5815,13 +5161,13 @@
         <p:spPr>
           <a:xfrm>
             <a:off x="0" y="0"/>
-            <a:ext cx="3931920" cy="6858000"/>
+            <a:ext cx="12191695" cy="1234440"/>
           </a:xfrm>
           <a:prstGeom prst="rect">
             <a:avLst/>
           </a:prstGeom>
           <a:solidFill>
-            <a:srgbClr val="205F61"/>
+            <a:srgbClr val="27B5CE"/>
           </a:solidFill>
           <a:ln>
             <a:noFill/>
@@ -5852,120 +5198,20 @@
       </p:sp>
       <p:sp>
         <p:nvSpPr>
-          <p:cNvPr id="3" name="TextBox 2"/>
-          <p:cNvSpPr txBox="1"/>
-          <p:nvPr/>
-        </p:nvSpPr>
-        <p:spPr>
-          <a:xfrm>
-            <a:off x="365760" y="2103120"/>
-            <a:ext cx="3291840" cy="2194560"/>
-          </a:xfrm>
-          <a:prstGeom prst="rect">
-            <a:avLst/>
-          </a:prstGeom>
-          <a:noFill/>
-        </p:spPr>
-        <p:txBody>
-          <a:bodyPr wrap="square" anchor="t" lIns="0" rIns="0" tIns="0" bIns="0">
-            <a:spAutoFit/>
-          </a:bodyPr>
-          <a:lstStyle/>
-          <a:p>
-            <a:r>
-              <a:rPr sz="13000" b="1" i="0">
-                <a:solidFill>
-                  <a:srgbClr val="FFFFFF"/>
-                </a:solidFill>
-                <a:latin typeface="Roboto"/>
-              </a:rPr>
-              <a:t>03</a:t>
-            </a:r>
-          </a:p>
-        </p:txBody>
-      </p:sp>
-      <p:sp>
-        <p:nvSpPr>
-          <p:cNvPr id="4" name="TextBox 3"/>
-          <p:cNvSpPr txBox="1"/>
-          <p:nvPr/>
-        </p:nvSpPr>
-        <p:spPr>
-          <a:xfrm>
-            <a:off x="4480560" y="2468880"/>
-            <a:ext cx="7132320" cy="2194560"/>
-          </a:xfrm>
-          <a:prstGeom prst="rect">
-            <a:avLst/>
-          </a:prstGeom>
-          <a:noFill/>
-        </p:spPr>
-        <p:txBody>
-          <a:bodyPr wrap="square" anchor="t" lIns="0" rIns="0" tIns="0" bIns="0">
-            <a:spAutoFit/>
-          </a:bodyPr>
-          <a:lstStyle/>
-          <a:p>
-            <a:r>
-              <a:rPr sz="1600" b="1" i="0">
-                <a:solidFill>
-                  <a:srgbClr val="205F61"/>
-                </a:solidFill>
-                <a:latin typeface="Roboto"/>
-              </a:rPr>
-              <a:t>SECTION</a:t>
-            </a:r>
-          </a:p>
-          <a:p>
-            <a:pPr>
-              <a:spcBef>
-                <a:spcPts val="600"/>
-              </a:spcBef>
-            </a:pPr>
-            <a:r>
-              <a:rPr sz="3800" b="1" i="0">
-                <a:solidFill>
-                  <a:srgbClr val="2A2929"/>
-                </a:solidFill>
-                <a:latin typeface="Roboto"/>
-              </a:rPr>
-              <a:t>Lodgement &amp; sign-off</a:t>
-            </a:r>
-          </a:p>
-          <a:p>
-            <a:pPr>
-              <a:spcBef>
-                <a:spcPts val="1000"/>
-              </a:spcBef>
-            </a:pPr>
-            <a:r>
-              <a:rPr sz="2000" b="0" i="1">
-                <a:solidFill>
-                  <a:srgbClr val="484848"/>
-                </a:solidFill>
-                <a:latin typeface="Roboto Light"/>
-              </a:rPr>
-              <a:t>lodge it, get it signed</a:t>
-            </a:r>
-          </a:p>
-        </p:txBody>
-      </p:sp>
-      <p:sp>
-        <p:nvSpPr>
-          <p:cNvPr id="5" name="Rectangle 4"/>
+          <p:cNvPr id="3" name="Rounded Rectangle 2"/>
           <p:cNvSpPr/>
           <p:nvPr/>
         </p:nvSpPr>
         <p:spPr>
           <a:xfrm>
-            <a:off x="0" y="6565392"/>
-            <a:ext cx="12191695" cy="38100"/>
-          </a:xfrm>
-          <a:prstGeom prst="rect">
+            <a:off x="640080" y="384048"/>
+            <a:ext cx="1691640" cy="457200"/>
+          </a:xfrm>
+          <a:prstGeom prst="roundRect">
             <a:avLst/>
           </a:prstGeom>
           <a:solidFill>
-            <a:srgbClr val="205F61"/>
+            <a:srgbClr val="2A2929"/>
           </a:solidFill>
           <a:ln>
             <a:noFill/>
@@ -5991,19 +5237,62 @@
           <a:lstStyle/>
           <a:p>
             <a:pPr algn="ctr"/>
-          </a:p>
-        </p:txBody>
-      </p:sp>
-      <p:sp>
-        <p:nvSpPr>
-          <p:cNvPr id="6" name="TextBox 5"/>
+            <a:r>
+              <a:rPr sz="1400" b="1" i="0">
+                <a:solidFill>
+                  <a:srgbClr val="FBB900"/>
+                </a:solidFill>
+                <a:latin typeface="Roboto"/>
+              </a:rPr>
+              <a:t>ACTIVITY</a:t>
+            </a:r>
+          </a:p>
+        </p:txBody>
+      </p:sp>
+      <p:sp>
+        <p:nvSpPr>
+          <p:cNvPr id="4" name="TextBox 3"/>
           <p:cNvSpPr txBox="1"/>
           <p:nvPr/>
         </p:nvSpPr>
         <p:spPr>
           <a:xfrm>
-            <a:off x="502920" y="6400800"/>
-            <a:ext cx="5486400" cy="320040"/>
+            <a:off x="2560320" y="310896"/>
+            <a:ext cx="8961120" cy="685800"/>
+          </a:xfrm>
+          <a:prstGeom prst="rect">
+            <a:avLst/>
+          </a:prstGeom>
+          <a:noFill/>
+        </p:spPr>
+        <p:txBody>
+          <a:bodyPr wrap="square" anchor="ctr" lIns="0" rIns="0" tIns="0" bIns="0">
+            <a:spAutoFit/>
+          </a:bodyPr>
+          <a:lstStyle/>
+          <a:p>
+            <a:r>
+              <a:rPr sz="2600" b="1" i="0">
+                <a:solidFill>
+                  <a:srgbClr val="FFFFFF"/>
+                </a:solidFill>
+                <a:latin typeface="Roboto"/>
+              </a:rPr>
+              <a:t>Run the walkthrough</a:t>
+            </a:r>
+          </a:p>
+        </p:txBody>
+      </p:sp>
+      <p:sp>
+        <p:nvSpPr>
+          <p:cNvPr id="5" name="TextBox 4"/>
+          <p:cNvSpPr txBox="1"/>
+          <p:nvPr/>
+        </p:nvSpPr>
+        <p:spPr>
+          <a:xfrm>
+            <a:off x="658368" y="1554480"/>
+            <a:ext cx="10881360" cy="4297680"/>
           </a:xfrm>
           <a:prstGeom prst="rect">
             <a:avLst/>
@@ -6016,24 +5305,112 @@
           </a:bodyPr>
           <a:lstStyle/>
           <a:p>
-            <a:r>
-              <a:rPr sz="1100" b="1" i="0">
+            <a:pPr marL="0" indent="0">
+              <a:lnSpc>
+                <a:spcPct val="105000"/>
+              </a:lnSpc>
+              <a:spcBef>
+                <a:spcPts val="0"/>
+              </a:spcBef>
+              <a:spcAft>
+                <a:spcPts val="1000"/>
+              </a:spcAft>
+            </a:pPr>
+            <a:r>
+              <a:rPr sz="1700" b="1" i="0">
+                <a:solidFill>
+                  <a:srgbClr val="EDAB0C"/>
+                </a:solidFill>
+                <a:latin typeface="Roboto"/>
+              </a:rPr>
+              <a:t>■  </a:t>
+            </a:r>
+            <a:r>
+              <a:rPr sz="1700" b="0" i="0">
                 <a:solidFill>
                   <a:srgbClr val="2A2929"/>
                 </a:solidFill>
                 <a:latin typeface="Roboto"/>
               </a:rPr>
-              <a:t>Kangan </a:t>
-            </a:r>
-            <a:r>
-              <a:rPr sz="1100" b="1" i="0">
-                <a:solidFill>
-                  <a:srgbClr val="D68E10"/>
-                </a:solidFill>
-                <a:latin typeface="Roboto"/>
-              </a:rPr>
-              <a:t>Institute</a:t>
-            </a:r>
+              <a:t>Workbook — tasks 40 and 41.</a:t>
+            </a:r>
+          </a:p>
+          <a:p>
+            <a:pPr marL="0" indent="0">
+              <a:lnSpc>
+                <a:spcPct val="105000"/>
+              </a:lnSpc>
+              <a:spcBef>
+                <a:spcPts val="0"/>
+              </a:spcBef>
+              <a:spcAft>
+                <a:spcPts val="1000"/>
+              </a:spcAft>
+            </a:pPr>
+            <a:r>
+              <a:rPr sz="1700" b="1" i="0">
+                <a:solidFill>
+                  <a:srgbClr val="EDAB0C"/>
+                </a:solidFill>
+                <a:latin typeface="Roboto"/>
+              </a:rPr>
+              <a:t>■  </a:t>
+            </a:r>
+            <a:r>
+              <a:rPr sz="1700" b="0" i="0">
+                <a:solidFill>
+                  <a:srgbClr val="2A2929"/>
+                </a:solidFill>
+                <a:latin typeface="Roboto"/>
+              </a:rPr>
+              <a:t>Conduct the walkthrough in pairs, record the session, then record the feedback you sought and how you responded.</a:t>
+            </a:r>
+          </a:p>
+        </p:txBody>
+      </p:sp>
+      <p:sp>
+        <p:nvSpPr>
+          <p:cNvPr id="6" name="Rounded Rectangle 5"/>
+          <p:cNvSpPr/>
+          <p:nvPr/>
+        </p:nvSpPr>
+        <p:spPr>
+          <a:xfrm>
+            <a:off x="640080" y="5897880"/>
+            <a:ext cx="4023360" cy="457200"/>
+          </a:xfrm>
+          <a:prstGeom prst="roundRect">
+            <a:avLst/>
+          </a:prstGeom>
+          <a:solidFill>
+            <a:srgbClr val="F9F9F9"/>
+          </a:solidFill>
+          <a:ln w="12700">
+            <a:solidFill>
+              <a:srgbClr val="CCCCCC"/>
+            </a:solidFill>
+          </a:ln>
+          <a:effectLst/>
+        </p:spPr>
+        <p:style>
+          <a:lnRef idx="1">
+            <a:schemeClr val="accent1"/>
+          </a:lnRef>
+          <a:fillRef idx="3">
+            <a:schemeClr val="accent1"/>
+          </a:fillRef>
+          <a:effectRef idx="2">
+            <a:schemeClr val="accent1"/>
+          </a:effectRef>
+          <a:fontRef idx="minor">
+            <a:schemeClr val="lt1"/>
+          </a:fontRef>
+        </p:style>
+        <p:txBody>
+          <a:bodyPr rtlCol="0" anchor="ctr"/>
+          <a:lstStyle/>
+          <a:p>
+            <a:pPr algn="ctr"/>
           </a:p>
         </p:txBody>
       </p:sp>
@@ -6045,8 +5422,86 @@
         </p:nvSpPr>
         <p:spPr>
           <a:xfrm>
-            <a:off x="10515600" y="6400800"/>
-            <a:ext cx="1188720" cy="320040"/>
+            <a:off x="822960" y="5943600"/>
+            <a:ext cx="3657600" cy="365760"/>
+          </a:xfrm>
+          <a:prstGeom prst="rect">
+            <a:avLst/>
+          </a:prstGeom>
+          <a:noFill/>
+        </p:spPr>
+        <p:txBody>
+          <a:bodyPr wrap="square" anchor="ctr" lIns="0" rIns="0" tIns="0" bIns="0">
+            <a:spAutoFit/>
+          </a:bodyPr>
+          <a:lstStyle/>
+          <a:p>
+            <a:r>
+              <a:rPr sz="1500" b="1" i="0">
+                <a:solidFill>
+                  <a:srgbClr val="2A2929"/>
+                </a:solidFill>
+                <a:latin typeface="Roboto"/>
+              </a:rPr>
+              <a:t>⏱  ~35 min</a:t>
+            </a:r>
+          </a:p>
+        </p:txBody>
+      </p:sp>
+      <p:sp>
+        <p:nvSpPr>
+          <p:cNvPr id="8" name="Rectangle 7"/>
+          <p:cNvSpPr/>
+          <p:nvPr/>
+        </p:nvSpPr>
+        <p:spPr>
+          <a:xfrm>
+            <a:off x="0" y="6565392"/>
+            <a:ext cx="12191695" cy="38100"/>
+          </a:xfrm>
+          <a:prstGeom prst="rect">
+            <a:avLst/>
+          </a:prstGeom>
+          <a:solidFill>
+            <a:srgbClr val="27B5CE"/>
+          </a:solidFill>
+          <a:ln>
+            <a:noFill/>
+          </a:ln>
+          <a:effectLst/>
+        </p:spPr>
+        <p:style>
+          <a:lnRef idx="1">
+            <a:schemeClr val="accent1"/>
+          </a:lnRef>
+          <a:fillRef idx="3">
+            <a:schemeClr val="accent1"/>
+          </a:fillRef>
+          <a:effectRef idx="2">
+            <a:schemeClr val="accent1"/>
+          </a:effectRef>
+          <a:fontRef idx="minor">
+            <a:schemeClr val="lt1"/>
+          </a:fontRef>
+        </p:style>
+        <p:txBody>
+          <a:bodyPr rtlCol="0" anchor="ctr"/>
+          <a:lstStyle/>
+          <a:p>
+            <a:pPr algn="ctr"/>
+          </a:p>
+        </p:txBody>
+      </p:sp>
+      <p:sp>
+        <p:nvSpPr>
+          <p:cNvPr id="9" name="TextBox 8"/>
+          <p:cNvSpPr txBox="1"/>
+          <p:nvPr/>
+        </p:nvSpPr>
+        <p:spPr>
+          <a:xfrm>
+            <a:off x="502920" y="6400800"/>
+            <a:ext cx="5486400" cy="320040"/>
           </a:xfrm>
           <a:prstGeom prst="rect">
             <a:avLst/>
@@ -6059,6 +5514,49 @@
           </a:bodyPr>
           <a:lstStyle/>
           <a:p>
+            <a:r>
+              <a:rPr sz="1100" b="1" i="0">
+                <a:solidFill>
+                  <a:srgbClr val="2A2929"/>
+                </a:solidFill>
+                <a:latin typeface="Roboto"/>
+              </a:rPr>
+              <a:t>Kangan </a:t>
+            </a:r>
+            <a:r>
+              <a:rPr sz="1100" b="1" i="0">
+                <a:solidFill>
+                  <a:srgbClr val="D68E10"/>
+                </a:solidFill>
+                <a:latin typeface="Roboto"/>
+              </a:rPr>
+              <a:t>Institute</a:t>
+            </a:r>
+          </a:p>
+        </p:txBody>
+      </p:sp>
+      <p:sp>
+        <p:nvSpPr>
+          <p:cNvPr id="10" name="TextBox 9"/>
+          <p:cNvSpPr txBox="1"/>
+          <p:nvPr/>
+        </p:nvSpPr>
+        <p:spPr>
+          <a:xfrm>
+            <a:off x="10515600" y="6400800"/>
+            <a:ext cx="1188720" cy="320040"/>
+          </a:xfrm>
+          <a:prstGeom prst="rect">
+            <a:avLst/>
+          </a:prstGeom>
+          <a:noFill/>
+        </p:spPr>
+        <p:txBody>
+          <a:bodyPr wrap="square" anchor="t" lIns="0" rIns="0" tIns="0" bIns="0">
+            <a:spAutoFit/>
+          </a:bodyPr>
+          <a:lstStyle/>
+          <a:p>
             <a:pPr algn="r"/>
             <a:r>
               <a:rPr sz="1100" b="0" i="0">
@@ -6067,7 +5565,7 @@
                 </a:solidFill>
                 <a:latin typeface="Roboto"/>
               </a:rPr>
-              <a:t/>
+              <a:t>9</a:t>
             </a:r>
           </a:p>
         </p:txBody>
@@ -6086,7 +5584,7 @@
     <p:bg>
       <p:bgPr>
         <a:solidFill>
-          <a:srgbClr val="FFFFFF"/>
+          <a:srgbClr val="F9F9F9"/>
         </a:solidFill>
         <a:effectLst/>
       </p:bgPr>
@@ -6106,8 +5604,8 @@
         </p:nvSpPr>
         <p:spPr>
           <a:xfrm>
-            <a:off x="640080" y="457200"/>
-            <a:ext cx="10881360" cy="960120"/>
+            <a:off x="640080" y="548640"/>
+            <a:ext cx="10881360" cy="1097280"/>
           </a:xfrm>
           <a:prstGeom prst="rect">
             <a:avLst/>
@@ -6121,13 +5619,29 @@
           <a:lstStyle/>
           <a:p>
             <a:r>
-              <a:rPr sz="2800" b="1" i="0">
+              <a:rPr sz="3200" b="1" i="0">
                 <a:solidFill>
                   <a:srgbClr val="2A2929"/>
                 </a:solidFill>
                 <a:latin typeface="Roboto"/>
               </a:rPr>
-              <a:t>Lodge &amp; obtain sign-off</a:t>
+              <a:t>Key takeaways</a:t>
+            </a:r>
+          </a:p>
+          <a:p>
+            <a:pPr>
+              <a:spcBef>
+                <a:spcPts val="200"/>
+              </a:spcBef>
+            </a:pPr>
+            <a:r>
+              <a:rPr sz="1800" b="1" i="0">
+                <a:solidFill>
+                  <a:srgbClr val="27B5CE"/>
+                </a:solidFill>
+                <a:latin typeface="Roboto"/>
+              </a:rPr>
+              <a:t>Section 2 · The session</a:t>
             </a:r>
           </a:p>
         </p:txBody>
@@ -6140,14 +5654,14 @@
         </p:nvSpPr>
         <p:spPr>
           <a:xfrm>
-            <a:off x="658368" y="1371600"/>
+            <a:off x="658368" y="1600200"/>
             <a:ext cx="1463040" cy="50800"/>
           </a:xfrm>
           <a:prstGeom prst="rect">
             <a:avLst/>
           </a:prstGeom>
           <a:solidFill>
-            <a:srgbClr val="205F61"/>
+            <a:srgbClr val="27B5CE"/>
           </a:solidFill>
           <a:ln>
             <a:noFill/>
@@ -6178,117 +5692,47 @@
       </p:sp>
       <p:sp>
         <p:nvSpPr>
-          <p:cNvPr id="4" name="TextBox 3"/>
-          <p:cNvSpPr txBox="1"/>
-          <p:nvPr/>
-        </p:nvSpPr>
-        <p:spPr>
-          <a:xfrm>
-            <a:off x="658368" y="1691640"/>
-            <a:ext cx="10881360" cy="4480560"/>
-          </a:xfrm>
-          <a:prstGeom prst="rect">
-            <a:avLst/>
-          </a:prstGeom>
-          <a:noFill/>
-        </p:spPr>
-        <p:txBody>
-          <a:bodyPr wrap="square" anchor="ctr" lIns="0" rIns="0" tIns="0" bIns="0">
-            <a:spAutoFit/>
-          </a:bodyPr>
-          <a:lstStyle/>
-          <a:p>
-            <a:pPr marL="0" indent="0">
-              <a:lnSpc>
-                <a:spcPct val="105000"/>
-              </a:lnSpc>
-              <a:spcBef>
-                <a:spcPts val="0"/>
-              </a:spcBef>
-              <a:spcAft>
-                <a:spcPts val="1000"/>
-              </a:spcAft>
-            </a:pPr>
-            <a:r>
-              <a:rPr sz="2400" b="1" i="0">
-                <a:solidFill>
-                  <a:srgbClr val="EDAB0C"/>
-                </a:solidFill>
-                <a:latin typeface="Roboto"/>
-              </a:rPr>
-              <a:t>■  </a:t>
-            </a:r>
-            <a:r>
-              <a:rPr sz="2400" b="0" i="0">
-                <a:solidFill>
-                  <a:srgbClr val="2A2929"/>
-                </a:solidFill>
-                <a:latin typeface="Roboto"/>
-              </a:rPr>
-              <a:t>Lodge the DR plan per the organisational and legislative protocol — the right place, the right record.</a:t>
-            </a:r>
-          </a:p>
-          <a:p>
-            <a:pPr marL="0" indent="0">
-              <a:lnSpc>
-                <a:spcPct val="105000"/>
-              </a:lnSpc>
-              <a:spcBef>
-                <a:spcPts val="0"/>
-              </a:spcBef>
-              <a:spcAft>
-                <a:spcPts val="1000"/>
-              </a:spcAft>
-            </a:pPr>
-            <a:r>
-              <a:rPr sz="2400" b="1" i="0">
-                <a:solidFill>
-                  <a:srgbClr val="EDAB0C"/>
-                </a:solidFill>
-                <a:latin typeface="Roboto"/>
-              </a:rPr>
-              <a:t>■  </a:t>
-            </a:r>
-            <a:r>
-              <a:rPr sz="2400" b="0" i="0">
-                <a:solidFill>
-                  <a:srgbClr val="2A2929"/>
-                </a:solidFill>
-                <a:latin typeface="Roboto"/>
-              </a:rPr>
-              <a:t>Obtain final sign-off from the required personnel — the formal acceptance.</a:t>
-            </a:r>
-          </a:p>
-          <a:p>
-            <a:pPr marL="0" indent="0">
-              <a:lnSpc>
-                <a:spcPct val="105000"/>
-              </a:lnSpc>
-              <a:spcBef>
-                <a:spcPts val="0"/>
-              </a:spcBef>
-              <a:spcAft>
-                <a:spcPts val="1000"/>
-              </a:spcAft>
-            </a:pPr>
-            <a:r>
-              <a:rPr sz="2400" b="1" i="0">
-                <a:solidFill>
-                  <a:srgbClr val="EDAB0C"/>
-                </a:solidFill>
-                <a:latin typeface="Roboto"/>
-              </a:rPr>
-              <a:t>■  </a:t>
-            </a:r>
-            <a:r>
-              <a:rPr sz="2400" b="0" i="0">
-                <a:solidFill>
-                  <a:srgbClr val="2A2929"/>
-                </a:solidFill>
-                <a:latin typeface="Roboto"/>
-              </a:rPr>
-              <a:t>Sign-off is the gate to AT2: nothing is built until the design is approved.</a:t>
-            </a:r>
+          <p:cNvPr id="4" name="Rectangle 3"/>
+          <p:cNvSpPr/>
+          <p:nvPr/>
+        </p:nvSpPr>
+        <p:spPr>
+          <a:xfrm>
+            <a:off x="640080" y="1965960"/>
+            <a:ext cx="10927080" cy="841248"/>
+          </a:xfrm>
+          <a:prstGeom prst="rect">
+            <a:avLst/>
+          </a:prstGeom>
+          <a:solidFill>
+            <a:srgbClr val="FFFFFF"/>
+          </a:solidFill>
+          <a:ln w="12700">
+            <a:solidFill>
+              <a:srgbClr val="CCCCCC"/>
+            </a:solidFill>
+          </a:ln>
+          <a:effectLst/>
+        </p:spPr>
+        <p:style>
+          <a:lnRef idx="1">
+            <a:schemeClr val="accent1"/>
+          </a:lnRef>
+          <a:fillRef idx="3">
+            <a:schemeClr val="accent1"/>
+          </a:fillRef>
+          <a:effectRef idx="2">
+            <a:schemeClr val="accent1"/>
+          </a:effectRef>
+          <a:fontRef idx="minor">
+            <a:schemeClr val="lt1"/>
+          </a:fontRef>
+        </p:style>
+        <p:txBody>
+          <a:bodyPr rtlCol="0" anchor="ctr"/>
+          <a:lstStyle/>
+          <a:p>
+            <a:pPr algn="ctr"/>
           </a:p>
         </p:txBody>
       </p:sp>
@@ -6300,14 +5744,14 @@
         </p:nvSpPr>
         <p:spPr>
           <a:xfrm>
-            <a:off x="0" y="6565392"/>
-            <a:ext cx="12191695" cy="38100"/>
+            <a:off x="640080" y="1965960"/>
+            <a:ext cx="109728" cy="841248"/>
           </a:xfrm>
           <a:prstGeom prst="rect">
             <a:avLst/>
           </a:prstGeom>
           <a:solidFill>
-            <a:srgbClr val="205F61"/>
+            <a:srgbClr val="27B5CE"/>
           </a:solidFill>
           <a:ln>
             <a:noFill/>
@@ -6344,6 +5788,218 @@
         </p:nvSpPr>
         <p:spPr>
           <a:xfrm>
+            <a:off x="960120" y="1965960"/>
+            <a:ext cx="10424160" cy="841248"/>
+          </a:xfrm>
+          <a:prstGeom prst="rect">
+            <a:avLst/>
+          </a:prstGeom>
+          <a:noFill/>
+        </p:spPr>
+        <p:txBody>
+          <a:bodyPr wrap="square" anchor="ctr" lIns="0" rIns="0" tIns="0" bIns="0">
+            <a:spAutoFit/>
+          </a:bodyPr>
+          <a:lstStyle/>
+          <a:p>
+            <a:pPr>
+              <a:lnSpc>
+                <a:spcPct val="100000"/>
+              </a:lnSpc>
+            </a:pPr>
+            <a:r>
+              <a:rPr sz="1700" b="0" i="0">
+                <a:solidFill>
+                  <a:srgbClr val="2A2929"/>
+                </a:solidFill>
+                <a:latin typeface="Roboto"/>
+              </a:rPr>
+              <a:t>Present to plan, inside the time, and record it immediately.</a:t>
+            </a:r>
+          </a:p>
+        </p:txBody>
+      </p:sp>
+      <p:sp>
+        <p:nvSpPr>
+          <p:cNvPr id="7" name="Rectangle 6"/>
+          <p:cNvSpPr/>
+          <p:nvPr/>
+        </p:nvSpPr>
+        <p:spPr>
+          <a:xfrm>
+            <a:off x="640080" y="2916936"/>
+            <a:ext cx="10927080" cy="841248"/>
+          </a:xfrm>
+          <a:prstGeom prst="rect">
+            <a:avLst/>
+          </a:prstGeom>
+          <a:solidFill>
+            <a:srgbClr val="FFFFFF"/>
+          </a:solidFill>
+          <a:ln w="12700">
+            <a:solidFill>
+              <a:srgbClr val="CCCCCC"/>
+            </a:solidFill>
+          </a:ln>
+          <a:effectLst/>
+        </p:spPr>
+        <p:style>
+          <a:lnRef idx="1">
+            <a:schemeClr val="accent1"/>
+          </a:lnRef>
+          <a:fillRef idx="3">
+            <a:schemeClr val="accent1"/>
+          </a:fillRef>
+          <a:effectRef idx="2">
+            <a:schemeClr val="accent1"/>
+          </a:effectRef>
+          <a:fontRef idx="minor">
+            <a:schemeClr val="lt1"/>
+          </a:fontRef>
+        </p:style>
+        <p:txBody>
+          <a:bodyPr rtlCol="0" anchor="ctr"/>
+          <a:lstStyle/>
+          <a:p>
+            <a:pPr algn="ctr"/>
+          </a:p>
+        </p:txBody>
+      </p:sp>
+      <p:sp>
+        <p:nvSpPr>
+          <p:cNvPr id="8" name="Rectangle 7"/>
+          <p:cNvSpPr/>
+          <p:nvPr/>
+        </p:nvSpPr>
+        <p:spPr>
+          <a:xfrm>
+            <a:off x="640080" y="2916936"/>
+            <a:ext cx="109728" cy="841248"/>
+          </a:xfrm>
+          <a:prstGeom prst="rect">
+            <a:avLst/>
+          </a:prstGeom>
+          <a:solidFill>
+            <a:srgbClr val="27B5CE"/>
+          </a:solidFill>
+          <a:ln>
+            <a:noFill/>
+          </a:ln>
+          <a:effectLst/>
+        </p:spPr>
+        <p:style>
+          <a:lnRef idx="1">
+            <a:schemeClr val="accent1"/>
+          </a:lnRef>
+          <a:fillRef idx="3">
+            <a:schemeClr val="accent1"/>
+          </a:fillRef>
+          <a:effectRef idx="2">
+            <a:schemeClr val="accent1"/>
+          </a:effectRef>
+          <a:fontRef idx="minor">
+            <a:schemeClr val="lt1"/>
+          </a:fontRef>
+        </p:style>
+        <p:txBody>
+          <a:bodyPr rtlCol="0" anchor="ctr"/>
+          <a:lstStyle/>
+          <a:p>
+            <a:pPr algn="ctr"/>
+          </a:p>
+        </p:txBody>
+      </p:sp>
+      <p:sp>
+        <p:nvSpPr>
+          <p:cNvPr id="9" name="TextBox 8"/>
+          <p:cNvSpPr txBox="1"/>
+          <p:nvPr/>
+        </p:nvSpPr>
+        <p:spPr>
+          <a:xfrm>
+            <a:off x="960120" y="2916936"/>
+            <a:ext cx="10424160" cy="841248"/>
+          </a:xfrm>
+          <a:prstGeom prst="rect">
+            <a:avLst/>
+          </a:prstGeom>
+          <a:noFill/>
+        </p:spPr>
+        <p:txBody>
+          <a:bodyPr wrap="square" anchor="ctr" lIns="0" rIns="0" tIns="0" bIns="0">
+            <a:spAutoFit/>
+          </a:bodyPr>
+          <a:lstStyle/>
+          <a:p>
+            <a:pPr>
+              <a:lnSpc>
+                <a:spcPct val="100000"/>
+              </a:lnSpc>
+            </a:pPr>
+            <a:r>
+              <a:rPr sz="1700" b="0" i="0">
+                <a:solidFill>
+                  <a:srgbClr val="2A2929"/>
+                </a:solidFill>
+                <a:latin typeface="Roboto"/>
+              </a:rPr>
+              <a:t>Seek the feedback; accept or defend with reasons; record both.</a:t>
+            </a:r>
+          </a:p>
+        </p:txBody>
+      </p:sp>
+      <p:sp>
+        <p:nvSpPr>
+          <p:cNvPr id="10" name="Rectangle 9"/>
+          <p:cNvSpPr/>
+          <p:nvPr/>
+        </p:nvSpPr>
+        <p:spPr>
+          <a:xfrm>
+            <a:off x="0" y="6565392"/>
+            <a:ext cx="12191695" cy="38100"/>
+          </a:xfrm>
+          <a:prstGeom prst="rect">
+            <a:avLst/>
+          </a:prstGeom>
+          <a:solidFill>
+            <a:srgbClr val="27B5CE"/>
+          </a:solidFill>
+          <a:ln>
+            <a:noFill/>
+          </a:ln>
+          <a:effectLst/>
+        </p:spPr>
+        <p:style>
+          <a:lnRef idx="1">
+            <a:schemeClr val="accent1"/>
+          </a:lnRef>
+          <a:fillRef idx="3">
+            <a:schemeClr val="accent1"/>
+          </a:fillRef>
+          <a:effectRef idx="2">
+            <a:schemeClr val="accent1"/>
+          </a:effectRef>
+          <a:fontRef idx="minor">
+            <a:schemeClr val="lt1"/>
+          </a:fontRef>
+        </p:style>
+        <p:txBody>
+          <a:bodyPr rtlCol="0" anchor="ctr"/>
+          <a:lstStyle/>
+          <a:p>
+            <a:pPr algn="ctr"/>
+          </a:p>
+        </p:txBody>
+      </p:sp>
+      <p:sp>
+        <p:nvSpPr>
+          <p:cNvPr id="11" name="TextBox 10"/>
+          <p:cNvSpPr txBox="1"/>
+          <p:nvPr/>
+        </p:nvSpPr>
+        <p:spPr>
+          <a:xfrm>
             <a:off x="502920" y="6400800"/>
             <a:ext cx="5486400" cy="320040"/>
           </a:xfrm>
@@ -6381,7 +6037,7 @@
       </p:sp>
       <p:sp>
         <p:nvSpPr>
-          <p:cNvPr id="7" name="TextBox 6"/>
+          <p:cNvPr id="12" name="TextBox 11"/>
           <p:cNvSpPr txBox="1"/>
           <p:nvPr/>
         </p:nvSpPr>
@@ -6409,7 +6065,7 @@
                 </a:solidFill>
                 <a:latin typeface="Roboto"/>
               </a:rPr>
-              <a:t>9</a:t>
+              <a:t>10</a:t>
             </a:r>
           </a:p>
         </p:txBody>
@@ -6449,7 +6105,7 @@
         <p:spPr>
           <a:xfrm>
             <a:off x="0" y="0"/>
-            <a:ext cx="12191695" cy="1234440"/>
+            <a:ext cx="3931920" cy="6858000"/>
           </a:xfrm>
           <a:prstGeom prst="rect">
             <a:avLst/>
@@ -6486,20 +6142,120 @@
       </p:sp>
       <p:sp>
         <p:nvSpPr>
-          <p:cNvPr id="3" name="Rounded Rectangle 2"/>
+          <p:cNvPr id="3" name="TextBox 2"/>
+          <p:cNvSpPr txBox="1"/>
+          <p:nvPr/>
+        </p:nvSpPr>
+        <p:spPr>
+          <a:xfrm>
+            <a:off x="365760" y="2103120"/>
+            <a:ext cx="3291840" cy="2194560"/>
+          </a:xfrm>
+          <a:prstGeom prst="rect">
+            <a:avLst/>
+          </a:prstGeom>
+          <a:noFill/>
+        </p:spPr>
+        <p:txBody>
+          <a:bodyPr wrap="square" anchor="t" lIns="0" rIns="0" tIns="0" bIns="0">
+            <a:spAutoFit/>
+          </a:bodyPr>
+          <a:lstStyle/>
+          <a:p>
+            <a:r>
+              <a:rPr sz="13000" b="1" i="0">
+                <a:solidFill>
+                  <a:srgbClr val="FFFFFF"/>
+                </a:solidFill>
+                <a:latin typeface="Roboto"/>
+              </a:rPr>
+              <a:t>03</a:t>
+            </a:r>
+          </a:p>
+        </p:txBody>
+      </p:sp>
+      <p:sp>
+        <p:nvSpPr>
+          <p:cNvPr id="4" name="TextBox 3"/>
+          <p:cNvSpPr txBox="1"/>
+          <p:nvPr/>
+        </p:nvSpPr>
+        <p:spPr>
+          <a:xfrm>
+            <a:off x="4480560" y="2468880"/>
+            <a:ext cx="7132320" cy="2194560"/>
+          </a:xfrm>
+          <a:prstGeom prst="rect">
+            <a:avLst/>
+          </a:prstGeom>
+          <a:noFill/>
+        </p:spPr>
+        <p:txBody>
+          <a:bodyPr wrap="square" anchor="t" lIns="0" rIns="0" tIns="0" bIns="0">
+            <a:spAutoFit/>
+          </a:bodyPr>
+          <a:lstStyle/>
+          <a:p>
+            <a:r>
+              <a:rPr sz="1600" b="1" i="0">
+                <a:solidFill>
+                  <a:srgbClr val="205F61"/>
+                </a:solidFill>
+                <a:latin typeface="Roboto"/>
+              </a:rPr>
+              <a:t>SECTION</a:t>
+            </a:r>
+          </a:p>
+          <a:p>
+            <a:pPr>
+              <a:spcBef>
+                <a:spcPts val="600"/>
+              </a:spcBef>
+            </a:pPr>
+            <a:r>
+              <a:rPr sz="3800" b="1" i="0">
+                <a:solidFill>
+                  <a:srgbClr val="2A2929"/>
+                </a:solidFill>
+                <a:latin typeface="Roboto"/>
+              </a:rPr>
+              <a:t>Lodgement and sign-off</a:t>
+            </a:r>
+          </a:p>
+          <a:p>
+            <a:pPr>
+              <a:spcBef>
+                <a:spcPts val="1000"/>
+              </a:spcBef>
+            </a:pPr>
+            <a:r>
+              <a:rPr sz="2000" b="0" i="1">
+                <a:solidFill>
+                  <a:srgbClr val="484848"/>
+                </a:solidFill>
+                <a:latin typeface="Roboto Light"/>
+              </a:rPr>
+              <a:t>filed where policy says, signed by who policy names</a:t>
+            </a:r>
+          </a:p>
+        </p:txBody>
+      </p:sp>
+      <p:sp>
+        <p:nvSpPr>
+          <p:cNvPr id="5" name="Rectangle 4"/>
           <p:cNvSpPr/>
           <p:nvPr/>
         </p:nvSpPr>
         <p:spPr>
           <a:xfrm>
-            <a:off x="640080" y="384048"/>
-            <a:ext cx="1691640" cy="457200"/>
-          </a:xfrm>
-          <a:prstGeom prst="roundRect">
+            <a:off x="0" y="6565392"/>
+            <a:ext cx="12191695" cy="38100"/>
+          </a:xfrm>
+          <a:prstGeom prst="rect">
             <a:avLst/>
           </a:prstGeom>
           <a:solidFill>
-            <a:srgbClr val="2A2929"/>
+            <a:srgbClr val="205F61"/>
           </a:solidFill>
           <a:ln>
             <a:noFill/>
@@ -6525,15 +6281,188 @@
           <a:lstStyle/>
           <a:p>
             <a:pPr algn="ctr"/>
-            <a:r>
-              <a:rPr sz="1400" b="1" i="0">
-                <a:solidFill>
-                  <a:srgbClr val="FBB900"/>
-                </a:solidFill>
-                <a:latin typeface="Roboto"/>
-              </a:rPr>
-              <a:t>ACTIVITY</a:t>
-            </a:r>
+          </a:p>
+        </p:txBody>
+      </p:sp>
+      <p:sp>
+        <p:nvSpPr>
+          <p:cNvPr id="6" name="TextBox 5"/>
+          <p:cNvSpPr txBox="1"/>
+          <p:nvPr/>
+        </p:nvSpPr>
+        <p:spPr>
+          <a:xfrm>
+            <a:off x="502920" y="6400800"/>
+            <a:ext cx="5486400" cy="320040"/>
+          </a:xfrm>
+          <a:prstGeom prst="rect">
+            <a:avLst/>
+          </a:prstGeom>
+          <a:noFill/>
+        </p:spPr>
+        <p:txBody>
+          <a:bodyPr wrap="square" anchor="t" lIns="0" rIns="0" tIns="0" bIns="0">
+            <a:spAutoFit/>
+          </a:bodyPr>
+          <a:lstStyle/>
+          <a:p>
+            <a:r>
+              <a:rPr sz="1100" b="1" i="0">
+                <a:solidFill>
+                  <a:srgbClr val="2A2929"/>
+                </a:solidFill>
+                <a:latin typeface="Roboto"/>
+              </a:rPr>
+              <a:t>Kangan </a:t>
+            </a:r>
+            <a:r>
+              <a:rPr sz="1100" b="1" i="0">
+                <a:solidFill>
+                  <a:srgbClr val="D68E10"/>
+                </a:solidFill>
+                <a:latin typeface="Roboto"/>
+              </a:rPr>
+              <a:t>Institute</a:t>
+            </a:r>
+          </a:p>
+        </p:txBody>
+      </p:sp>
+      <p:sp>
+        <p:nvSpPr>
+          <p:cNvPr id="7" name="TextBox 6"/>
+          <p:cNvSpPr txBox="1"/>
+          <p:nvPr/>
+        </p:nvSpPr>
+        <p:spPr>
+          <a:xfrm>
+            <a:off x="10515600" y="6400800"/>
+            <a:ext cx="1188720" cy="320040"/>
+          </a:xfrm>
+          <a:prstGeom prst="rect">
+            <a:avLst/>
+          </a:prstGeom>
+          <a:noFill/>
+        </p:spPr>
+        <p:txBody>
+          <a:bodyPr wrap="square" anchor="t" lIns="0" rIns="0" tIns="0" bIns="0">
+            <a:spAutoFit/>
+          </a:bodyPr>
+          <a:lstStyle/>
+          <a:p>
+            <a:pPr algn="r"/>
+            <a:r>
+              <a:rPr sz="1100" b="0" i="0">
+                <a:solidFill>
+                  <a:srgbClr val="7A7A7A"/>
+                </a:solidFill>
+                <a:latin typeface="Roboto"/>
+              </a:rPr>
+              <a:t/>
+            </a:r>
+          </a:p>
+        </p:txBody>
+      </p:sp>
+    </p:spTree>
+  </p:cSld>
+  <p:clrMapOvr>
+    <a:masterClrMapping/>
+  </p:clrMapOvr>
+</p:sld>
+</file>
+
+<file path=ppt/slides/slide15.xml><?xml version="1.0" encoding="utf-8"?>
+<p:sld xmlns:a="http://schemas.openxmlformats.org/drawingml/2006/main" xmlns:p="http://schemas.openxmlformats.org/presentationml/2006/main" xmlns:r="http://schemas.openxmlformats.org/officeDocument/2006/relationships">
+  <p:cSld>
+    <p:bg>
+      <p:bgPr>
+        <a:solidFill>
+          <a:srgbClr val="FFFFFF"/>
+        </a:solidFill>
+        <a:effectLst/>
+      </p:bgPr>
+    </p:bg>
+    <p:spTree>
+      <p:nvGrpSpPr>
+        <p:cNvPr id="1" name=""/>
+        <p:cNvGrpSpPr/>
+        <p:nvPr/>
+      </p:nvGrpSpPr>
+      <p:grpSpPr/>
+      <p:sp>
+        <p:nvSpPr>
+          <p:cNvPr id="2" name="TextBox 1"/>
+          <p:cNvSpPr txBox="1"/>
+          <p:nvPr/>
+        </p:nvSpPr>
+        <p:spPr>
+          <a:xfrm>
+            <a:off x="640080" y="457200"/>
+            <a:ext cx="10881360" cy="960120"/>
+          </a:xfrm>
+          <a:prstGeom prst="rect">
+            <a:avLst/>
+          </a:prstGeom>
+          <a:noFill/>
+        </p:spPr>
+        <p:txBody>
+          <a:bodyPr wrap="square" anchor="t" lIns="0" rIns="0" tIns="0" bIns="0">
+            <a:spAutoFit/>
+          </a:bodyPr>
+          <a:lstStyle/>
+          <a:p>
+            <a:r>
+              <a:rPr sz="2800" b="1" i="0">
+                <a:solidFill>
+                  <a:srgbClr val="2A2929"/>
+                </a:solidFill>
+                <a:latin typeface="Roboto"/>
+              </a:rPr>
+              <a:t>Lodge the plan</a:t>
+            </a:r>
+          </a:p>
+        </p:txBody>
+      </p:sp>
+      <p:sp>
+        <p:nvSpPr>
+          <p:cNvPr id="3" name="Rectangle 2"/>
+          <p:cNvSpPr/>
+          <p:nvPr/>
+        </p:nvSpPr>
+        <p:spPr>
+          <a:xfrm>
+            <a:off x="658368" y="1371600"/>
+            <a:ext cx="1463040" cy="50800"/>
+          </a:xfrm>
+          <a:prstGeom prst="rect">
+            <a:avLst/>
+          </a:prstGeom>
+          <a:solidFill>
+            <a:srgbClr val="205F61"/>
+          </a:solidFill>
+          <a:ln>
+            <a:noFill/>
+          </a:ln>
+          <a:effectLst/>
+        </p:spPr>
+        <p:style>
+          <a:lnRef idx="1">
+            <a:schemeClr val="accent1"/>
+          </a:lnRef>
+          <a:fillRef idx="3">
+            <a:schemeClr val="accent1"/>
+          </a:fillRef>
+          <a:effectRef idx="2">
+            <a:schemeClr val="accent1"/>
+          </a:effectRef>
+          <a:fontRef idx="minor">
+            <a:schemeClr val="lt1"/>
+          </a:fontRef>
+        </p:style>
+        <p:txBody>
+          <a:bodyPr rtlCol="0" anchor="ctr"/>
+          <a:lstStyle/>
+          <a:p>
+            <a:pPr algn="ctr"/>
           </a:p>
         </p:txBody>
       </p:sp>
@@ -6545,8 +6474,8 @@
         </p:nvSpPr>
         <p:spPr>
           <a:xfrm>
-            <a:off x="2560320" y="310896"/>
-            <a:ext cx="8961120" cy="685800"/>
+            <a:off x="658368" y="1691640"/>
+            <a:ext cx="10881360" cy="4480560"/>
           </a:xfrm>
           <a:prstGeom prst="rect">
             <a:avLst/>
@@ -6555,40 +6484,6 @@
         </p:spPr>
         <p:txBody>
           <a:bodyPr wrap="square" anchor="ctr" lIns="0" rIns="0" tIns="0" bIns="0">
-            <a:spAutoFit/>
-          </a:bodyPr>
-          <a:lstStyle/>
-          <a:p>
-            <a:r>
-              <a:rPr sz="2600" b="1" i="0">
-                <a:solidFill>
-                  <a:srgbClr val="FFFFFF"/>
-                </a:solidFill>
-                <a:latin typeface="Roboto"/>
-              </a:rPr>
-              <a:t>Lodgement &amp; sign-off</a:t>
-            </a:r>
-          </a:p>
-        </p:txBody>
-      </p:sp>
-      <p:sp>
-        <p:nvSpPr>
-          <p:cNvPr id="5" name="TextBox 4"/>
-          <p:cNvSpPr txBox="1"/>
-          <p:nvPr/>
-        </p:nvSpPr>
-        <p:spPr>
-          <a:xfrm>
-            <a:off x="658368" y="1554480"/>
-            <a:ext cx="10881360" cy="4297680"/>
-          </a:xfrm>
-          <a:prstGeom prst="rect">
-            <a:avLst/>
-          </a:prstGeom>
-          <a:noFill/>
-        </p:spPr>
-        <p:txBody>
-          <a:bodyPr wrap="square" anchor="t" lIns="0" rIns="0" tIns="0" bIns="0">
             <a:spAutoFit/>
           </a:bodyPr>
           <a:lstStyle/>
@@ -6605,7 +6500,7 @@
               </a:spcAft>
             </a:pPr>
             <a:r>
-              <a:rPr sz="1700" b="1" i="0">
+              <a:rPr sz="2400" b="1" i="0">
                 <a:solidFill>
                   <a:srgbClr val="EDAB0C"/>
                 </a:solidFill>
@@ -6614,13 +6509,13 @@
               <a:t>■  </a:t>
             </a:r>
             <a:r>
-              <a:rPr sz="1700" b="0" i="0">
+              <a:rPr sz="2400" b="0" i="0">
                 <a:solidFill>
                   <a:srgbClr val="2A2929"/>
                 </a:solidFill>
                 <a:latin typeface="Roboto"/>
               </a:rPr>
-              <a:t>For the practice scenario, lodge the DR plan per protocol.</a:t>
+              <a:t>The organisation's records policy says where a completed engagement document goes — read it, and follow it.</a:t>
             </a:r>
           </a:p>
           <a:p>
@@ -6636,6 +6531,712 @@
               </a:spcAft>
             </a:pPr>
             <a:r>
+              <a:rPr sz="2400" b="1" i="0">
+                <a:solidFill>
+                  <a:srgbClr val="EDAB0C"/>
+                </a:solidFill>
+                <a:latin typeface="Roboto"/>
+              </a:rPr>
+              <a:t>■  </a:t>
+            </a:r>
+            <a:r>
+              <a:rPr sz="2400" b="0" i="0">
+                <a:solidFill>
+                  <a:srgbClr val="2A2929"/>
+                </a:solidFill>
+                <a:latin typeface="Roboto"/>
+              </a:rPr>
+              <a:t>Lodgement is what makes the plan findable in a disaster; a plan nobody can find recovers nothing.</a:t>
+            </a:r>
+          </a:p>
+          <a:p>
+            <a:pPr marL="0" indent="0">
+              <a:lnSpc>
+                <a:spcPct val="105000"/>
+              </a:lnSpc>
+              <a:spcBef>
+                <a:spcPts val="0"/>
+              </a:spcBef>
+              <a:spcAft>
+                <a:spcPts val="1000"/>
+              </a:spcAft>
+            </a:pPr>
+            <a:r>
+              <a:rPr sz="2400" b="1" i="0">
+                <a:solidFill>
+                  <a:srgbClr val="EDAB0C"/>
+                </a:solidFill>
+                <a:latin typeface="Roboto"/>
+              </a:rPr>
+              <a:t>■  </a:t>
+            </a:r>
+            <a:r>
+              <a:rPr sz="2400" b="0" i="0">
+                <a:solidFill>
+                  <a:srgbClr val="2A2929"/>
+                </a:solidFill>
+                <a:latin typeface="Roboto"/>
+              </a:rPr>
+              <a:t>Record where you lodged it and under what policy.</a:t>
+            </a:r>
+          </a:p>
+        </p:txBody>
+      </p:sp>
+      <p:sp>
+        <p:nvSpPr>
+          <p:cNvPr id="5" name="Rectangle 4"/>
+          <p:cNvSpPr/>
+          <p:nvPr/>
+        </p:nvSpPr>
+        <p:spPr>
+          <a:xfrm>
+            <a:off x="0" y="6565392"/>
+            <a:ext cx="12191695" cy="38100"/>
+          </a:xfrm>
+          <a:prstGeom prst="rect">
+            <a:avLst/>
+          </a:prstGeom>
+          <a:solidFill>
+            <a:srgbClr val="205F61"/>
+          </a:solidFill>
+          <a:ln>
+            <a:noFill/>
+          </a:ln>
+          <a:effectLst/>
+        </p:spPr>
+        <p:style>
+          <a:lnRef idx="1">
+            <a:schemeClr val="accent1"/>
+          </a:lnRef>
+          <a:fillRef idx="3">
+            <a:schemeClr val="accent1"/>
+          </a:fillRef>
+          <a:effectRef idx="2">
+            <a:schemeClr val="accent1"/>
+          </a:effectRef>
+          <a:fontRef idx="minor">
+            <a:schemeClr val="lt1"/>
+          </a:fontRef>
+        </p:style>
+        <p:txBody>
+          <a:bodyPr rtlCol="0" anchor="ctr"/>
+          <a:lstStyle/>
+          <a:p>
+            <a:pPr algn="ctr"/>
+          </a:p>
+        </p:txBody>
+      </p:sp>
+      <p:sp>
+        <p:nvSpPr>
+          <p:cNvPr id="6" name="TextBox 5"/>
+          <p:cNvSpPr txBox="1"/>
+          <p:nvPr/>
+        </p:nvSpPr>
+        <p:spPr>
+          <a:xfrm>
+            <a:off x="502920" y="6400800"/>
+            <a:ext cx="5486400" cy="320040"/>
+          </a:xfrm>
+          <a:prstGeom prst="rect">
+            <a:avLst/>
+          </a:prstGeom>
+          <a:noFill/>
+        </p:spPr>
+        <p:txBody>
+          <a:bodyPr wrap="square" anchor="t" lIns="0" rIns="0" tIns="0" bIns="0">
+            <a:spAutoFit/>
+          </a:bodyPr>
+          <a:lstStyle/>
+          <a:p>
+            <a:r>
+              <a:rPr sz="1100" b="1" i="0">
+                <a:solidFill>
+                  <a:srgbClr val="2A2929"/>
+                </a:solidFill>
+                <a:latin typeface="Roboto"/>
+              </a:rPr>
+              <a:t>Kangan </a:t>
+            </a:r>
+            <a:r>
+              <a:rPr sz="1100" b="1" i="0">
+                <a:solidFill>
+                  <a:srgbClr val="D68E10"/>
+                </a:solidFill>
+                <a:latin typeface="Roboto"/>
+              </a:rPr>
+              <a:t>Institute</a:t>
+            </a:r>
+          </a:p>
+        </p:txBody>
+      </p:sp>
+      <p:sp>
+        <p:nvSpPr>
+          <p:cNvPr id="7" name="TextBox 6"/>
+          <p:cNvSpPr txBox="1"/>
+          <p:nvPr/>
+        </p:nvSpPr>
+        <p:spPr>
+          <a:xfrm>
+            <a:off x="10515600" y="6400800"/>
+            <a:ext cx="1188720" cy="320040"/>
+          </a:xfrm>
+          <a:prstGeom prst="rect">
+            <a:avLst/>
+          </a:prstGeom>
+          <a:noFill/>
+        </p:spPr>
+        <p:txBody>
+          <a:bodyPr wrap="square" anchor="t" lIns="0" rIns="0" tIns="0" bIns="0">
+            <a:spAutoFit/>
+          </a:bodyPr>
+          <a:lstStyle/>
+          <a:p>
+            <a:pPr algn="r"/>
+            <a:r>
+              <a:rPr sz="1100" b="0" i="0">
+                <a:solidFill>
+                  <a:srgbClr val="7A7A7A"/>
+                </a:solidFill>
+                <a:latin typeface="Roboto"/>
+              </a:rPr>
+              <a:t>11</a:t>
+            </a:r>
+          </a:p>
+        </p:txBody>
+      </p:sp>
+    </p:spTree>
+  </p:cSld>
+  <p:clrMapOvr>
+    <a:masterClrMapping/>
+  </p:clrMapOvr>
+</p:sld>
+</file>
+
+<file path=ppt/slides/slide16.xml><?xml version="1.0" encoding="utf-8"?>
+<p:sld xmlns:a="http://schemas.openxmlformats.org/drawingml/2006/main" xmlns:p="http://schemas.openxmlformats.org/presentationml/2006/main" xmlns:r="http://schemas.openxmlformats.org/officeDocument/2006/relationships">
+  <p:cSld>
+    <p:bg>
+      <p:bgPr>
+        <a:solidFill>
+          <a:srgbClr val="FFFFFF"/>
+        </a:solidFill>
+        <a:effectLst/>
+      </p:bgPr>
+    </p:bg>
+    <p:spTree>
+      <p:nvGrpSpPr>
+        <p:cNvPr id="1" name=""/>
+        <p:cNvGrpSpPr/>
+        <p:nvPr/>
+      </p:nvGrpSpPr>
+      <p:grpSpPr/>
+      <p:sp>
+        <p:nvSpPr>
+          <p:cNvPr id="2" name="TextBox 1"/>
+          <p:cNvSpPr txBox="1"/>
+          <p:nvPr/>
+        </p:nvSpPr>
+        <p:spPr>
+          <a:xfrm>
+            <a:off x="640080" y="457200"/>
+            <a:ext cx="10881360" cy="960120"/>
+          </a:xfrm>
+          <a:prstGeom prst="rect">
+            <a:avLst/>
+          </a:prstGeom>
+          <a:noFill/>
+        </p:spPr>
+        <p:txBody>
+          <a:bodyPr wrap="square" anchor="t" lIns="0" rIns="0" tIns="0" bIns="0">
+            <a:spAutoFit/>
+          </a:bodyPr>
+          <a:lstStyle/>
+          <a:p>
+            <a:r>
+              <a:rPr sz="2800" b="1" i="0">
+                <a:solidFill>
+                  <a:srgbClr val="2A2929"/>
+                </a:solidFill>
+                <a:latin typeface="Roboto"/>
+              </a:rPr>
+              <a:t>Obtain sign-off</a:t>
+            </a:r>
+          </a:p>
+        </p:txBody>
+      </p:sp>
+      <p:sp>
+        <p:nvSpPr>
+          <p:cNvPr id="3" name="Rectangle 2"/>
+          <p:cNvSpPr/>
+          <p:nvPr/>
+        </p:nvSpPr>
+        <p:spPr>
+          <a:xfrm>
+            <a:off x="658368" y="1371600"/>
+            <a:ext cx="1463040" cy="50800"/>
+          </a:xfrm>
+          <a:prstGeom prst="rect">
+            <a:avLst/>
+          </a:prstGeom>
+          <a:solidFill>
+            <a:srgbClr val="205F61"/>
+          </a:solidFill>
+          <a:ln>
+            <a:noFill/>
+          </a:ln>
+          <a:effectLst/>
+        </p:spPr>
+        <p:style>
+          <a:lnRef idx="1">
+            <a:schemeClr val="accent1"/>
+          </a:lnRef>
+          <a:fillRef idx="3">
+            <a:schemeClr val="accent1"/>
+          </a:fillRef>
+          <a:effectRef idx="2">
+            <a:schemeClr val="accent1"/>
+          </a:effectRef>
+          <a:fontRef idx="minor">
+            <a:schemeClr val="lt1"/>
+          </a:fontRef>
+        </p:style>
+        <p:txBody>
+          <a:bodyPr rtlCol="0" anchor="ctr"/>
+          <a:lstStyle/>
+          <a:p>
+            <a:pPr algn="ctr"/>
+          </a:p>
+        </p:txBody>
+      </p:sp>
+      <p:sp>
+        <p:nvSpPr>
+          <p:cNvPr id="4" name="TextBox 3"/>
+          <p:cNvSpPr txBox="1"/>
+          <p:nvPr/>
+        </p:nvSpPr>
+        <p:spPr>
+          <a:xfrm>
+            <a:off x="658368" y="1691640"/>
+            <a:ext cx="10881360" cy="4480560"/>
+          </a:xfrm>
+          <a:prstGeom prst="rect">
+            <a:avLst/>
+          </a:prstGeom>
+          <a:noFill/>
+        </p:spPr>
+        <p:txBody>
+          <a:bodyPr wrap="square" anchor="ctr" lIns="0" rIns="0" tIns="0" bIns="0">
+            <a:spAutoFit/>
+          </a:bodyPr>
+          <a:lstStyle/>
+          <a:p>
+            <a:pPr marL="0" indent="0">
+              <a:lnSpc>
+                <a:spcPct val="105000"/>
+              </a:lnSpc>
+              <a:spcBef>
+                <a:spcPts val="0"/>
+              </a:spcBef>
+              <a:spcAft>
+                <a:spcPts val="1000"/>
+              </a:spcAft>
+            </a:pPr>
+            <a:r>
+              <a:rPr sz="2400" b="1" i="0">
+                <a:solidFill>
+                  <a:srgbClr val="EDAB0C"/>
+                </a:solidFill>
+                <a:latin typeface="Roboto"/>
+              </a:rPr>
+              <a:t>■  </a:t>
+            </a:r>
+            <a:r>
+              <a:rPr sz="2400" b="0" i="0">
+                <a:solidFill>
+                  <a:srgbClr val="2A2929"/>
+                </a:solidFill>
+                <a:latin typeface="Roboto"/>
+              </a:rPr>
+              <a:t>Ask for the decision, and record it: approved, approved with conditions, or not yet.</a:t>
+            </a:r>
+          </a:p>
+          <a:p>
+            <a:pPr marL="0" indent="0">
+              <a:lnSpc>
+                <a:spcPct val="105000"/>
+              </a:lnSpc>
+              <a:spcBef>
+                <a:spcPts val="0"/>
+              </a:spcBef>
+              <a:spcAft>
+                <a:spcPts val="1000"/>
+              </a:spcAft>
+            </a:pPr>
+            <a:r>
+              <a:rPr sz="2400" b="1" i="0">
+                <a:solidFill>
+                  <a:srgbClr val="EDAB0C"/>
+                </a:solidFill>
+                <a:latin typeface="Roboto"/>
+              </a:rPr>
+              <a:t>■  </a:t>
+            </a:r>
+            <a:r>
+              <a:rPr sz="2400" b="0" i="0">
+                <a:solidFill>
+                  <a:srgbClr val="2A2929"/>
+                </a:solidFill>
+                <a:latin typeface="Roboto"/>
+              </a:rPr>
+              <a:t>Approval with conditions is a real outcome, not a failure — record the conditions and what happens next.</a:t>
+            </a:r>
+          </a:p>
+          <a:p>
+            <a:pPr marL="0" indent="0">
+              <a:lnSpc>
+                <a:spcPct val="105000"/>
+              </a:lnSpc>
+              <a:spcBef>
+                <a:spcPts val="0"/>
+              </a:spcBef>
+              <a:spcAft>
+                <a:spcPts val="1000"/>
+              </a:spcAft>
+            </a:pPr>
+            <a:r>
+              <a:rPr sz="2400" b="1" i="0">
+                <a:solidFill>
+                  <a:srgbClr val="EDAB0C"/>
+                </a:solidFill>
+                <a:latin typeface="Roboto"/>
+              </a:rPr>
+              <a:t>■  </a:t>
+            </a:r>
+            <a:r>
+              <a:rPr sz="2400" b="0" i="0">
+                <a:solidFill>
+                  <a:srgbClr val="2A2929"/>
+                </a:solidFill>
+                <a:latin typeface="Roboto"/>
+              </a:rPr>
+              <a:t>Sign-off closes the engagement; the record of it is the evidence.</a:t>
+            </a:r>
+          </a:p>
+        </p:txBody>
+      </p:sp>
+      <p:sp>
+        <p:nvSpPr>
+          <p:cNvPr id="5" name="Rectangle 4"/>
+          <p:cNvSpPr/>
+          <p:nvPr/>
+        </p:nvSpPr>
+        <p:spPr>
+          <a:xfrm>
+            <a:off x="0" y="6565392"/>
+            <a:ext cx="12191695" cy="38100"/>
+          </a:xfrm>
+          <a:prstGeom prst="rect">
+            <a:avLst/>
+          </a:prstGeom>
+          <a:solidFill>
+            <a:srgbClr val="205F61"/>
+          </a:solidFill>
+          <a:ln>
+            <a:noFill/>
+          </a:ln>
+          <a:effectLst/>
+        </p:spPr>
+        <p:style>
+          <a:lnRef idx="1">
+            <a:schemeClr val="accent1"/>
+          </a:lnRef>
+          <a:fillRef idx="3">
+            <a:schemeClr val="accent1"/>
+          </a:fillRef>
+          <a:effectRef idx="2">
+            <a:schemeClr val="accent1"/>
+          </a:effectRef>
+          <a:fontRef idx="minor">
+            <a:schemeClr val="lt1"/>
+          </a:fontRef>
+        </p:style>
+        <p:txBody>
+          <a:bodyPr rtlCol="0" anchor="ctr"/>
+          <a:lstStyle/>
+          <a:p>
+            <a:pPr algn="ctr"/>
+          </a:p>
+        </p:txBody>
+      </p:sp>
+      <p:sp>
+        <p:nvSpPr>
+          <p:cNvPr id="6" name="TextBox 5"/>
+          <p:cNvSpPr txBox="1"/>
+          <p:nvPr/>
+        </p:nvSpPr>
+        <p:spPr>
+          <a:xfrm>
+            <a:off x="502920" y="6400800"/>
+            <a:ext cx="5486400" cy="320040"/>
+          </a:xfrm>
+          <a:prstGeom prst="rect">
+            <a:avLst/>
+          </a:prstGeom>
+          <a:noFill/>
+        </p:spPr>
+        <p:txBody>
+          <a:bodyPr wrap="square" anchor="t" lIns="0" rIns="0" tIns="0" bIns="0">
+            <a:spAutoFit/>
+          </a:bodyPr>
+          <a:lstStyle/>
+          <a:p>
+            <a:r>
+              <a:rPr sz="1100" b="1" i="0">
+                <a:solidFill>
+                  <a:srgbClr val="2A2929"/>
+                </a:solidFill>
+                <a:latin typeface="Roboto"/>
+              </a:rPr>
+              <a:t>Kangan </a:t>
+            </a:r>
+            <a:r>
+              <a:rPr sz="1100" b="1" i="0">
+                <a:solidFill>
+                  <a:srgbClr val="D68E10"/>
+                </a:solidFill>
+                <a:latin typeface="Roboto"/>
+              </a:rPr>
+              <a:t>Institute</a:t>
+            </a:r>
+          </a:p>
+        </p:txBody>
+      </p:sp>
+      <p:sp>
+        <p:nvSpPr>
+          <p:cNvPr id="7" name="TextBox 6"/>
+          <p:cNvSpPr txBox="1"/>
+          <p:nvPr/>
+        </p:nvSpPr>
+        <p:spPr>
+          <a:xfrm>
+            <a:off x="10515600" y="6400800"/>
+            <a:ext cx="1188720" cy="320040"/>
+          </a:xfrm>
+          <a:prstGeom prst="rect">
+            <a:avLst/>
+          </a:prstGeom>
+          <a:noFill/>
+        </p:spPr>
+        <p:txBody>
+          <a:bodyPr wrap="square" anchor="t" lIns="0" rIns="0" tIns="0" bIns="0">
+            <a:spAutoFit/>
+          </a:bodyPr>
+          <a:lstStyle/>
+          <a:p>
+            <a:pPr algn="r"/>
+            <a:r>
+              <a:rPr sz="1100" b="0" i="0">
+                <a:solidFill>
+                  <a:srgbClr val="7A7A7A"/>
+                </a:solidFill>
+                <a:latin typeface="Roboto"/>
+              </a:rPr>
+              <a:t>12</a:t>
+            </a:r>
+          </a:p>
+        </p:txBody>
+      </p:sp>
+    </p:spTree>
+  </p:cSld>
+  <p:clrMapOvr>
+    <a:masterClrMapping/>
+  </p:clrMapOvr>
+</p:sld>
+</file>
+
+<file path=ppt/slides/slide17.xml><?xml version="1.0" encoding="utf-8"?>
+<p:sld xmlns:a="http://schemas.openxmlformats.org/drawingml/2006/main" xmlns:p="http://schemas.openxmlformats.org/presentationml/2006/main" xmlns:r="http://schemas.openxmlformats.org/officeDocument/2006/relationships">
+  <p:cSld>
+    <p:bg>
+      <p:bgPr>
+        <a:solidFill>
+          <a:srgbClr val="FFFFFF"/>
+        </a:solidFill>
+        <a:effectLst/>
+      </p:bgPr>
+    </p:bg>
+    <p:spTree>
+      <p:nvGrpSpPr>
+        <p:cNvPr id="1" name=""/>
+        <p:cNvGrpSpPr/>
+        <p:nvPr/>
+      </p:nvGrpSpPr>
+      <p:grpSpPr/>
+      <p:sp>
+        <p:nvSpPr>
+          <p:cNvPr id="2" name="Rectangle 1"/>
+          <p:cNvSpPr/>
+          <p:nvPr/>
+        </p:nvSpPr>
+        <p:spPr>
+          <a:xfrm>
+            <a:off x="0" y="0"/>
+            <a:ext cx="12191695" cy="1234440"/>
+          </a:xfrm>
+          <a:prstGeom prst="rect">
+            <a:avLst/>
+          </a:prstGeom>
+          <a:solidFill>
+            <a:srgbClr val="205F61"/>
+          </a:solidFill>
+          <a:ln>
+            <a:noFill/>
+          </a:ln>
+          <a:effectLst/>
+        </p:spPr>
+        <p:style>
+          <a:lnRef idx="1">
+            <a:schemeClr val="accent1"/>
+          </a:lnRef>
+          <a:fillRef idx="3">
+            <a:schemeClr val="accent1"/>
+          </a:fillRef>
+          <a:effectRef idx="2">
+            <a:schemeClr val="accent1"/>
+          </a:effectRef>
+          <a:fontRef idx="minor">
+            <a:schemeClr val="lt1"/>
+          </a:fontRef>
+        </p:style>
+        <p:txBody>
+          <a:bodyPr rtlCol="0" anchor="ctr"/>
+          <a:lstStyle/>
+          <a:p>
+            <a:pPr algn="ctr"/>
+          </a:p>
+        </p:txBody>
+      </p:sp>
+      <p:sp>
+        <p:nvSpPr>
+          <p:cNvPr id="3" name="Rounded Rectangle 2"/>
+          <p:cNvSpPr/>
+          <p:nvPr/>
+        </p:nvSpPr>
+        <p:spPr>
+          <a:xfrm>
+            <a:off x="640080" y="384048"/>
+            <a:ext cx="1691640" cy="457200"/>
+          </a:xfrm>
+          <a:prstGeom prst="roundRect">
+            <a:avLst/>
+          </a:prstGeom>
+          <a:solidFill>
+            <a:srgbClr val="2A2929"/>
+          </a:solidFill>
+          <a:ln>
+            <a:noFill/>
+          </a:ln>
+          <a:effectLst/>
+        </p:spPr>
+        <p:style>
+          <a:lnRef idx="1">
+            <a:schemeClr val="accent1"/>
+          </a:lnRef>
+          <a:fillRef idx="3">
+            <a:schemeClr val="accent1"/>
+          </a:fillRef>
+          <a:effectRef idx="2">
+            <a:schemeClr val="accent1"/>
+          </a:effectRef>
+          <a:fontRef idx="minor">
+            <a:schemeClr val="lt1"/>
+          </a:fontRef>
+        </p:style>
+        <p:txBody>
+          <a:bodyPr rtlCol="0" anchor="ctr"/>
+          <a:lstStyle/>
+          <a:p>
+            <a:pPr algn="ctr"/>
+            <a:r>
+              <a:rPr sz="1400" b="1" i="0">
+                <a:solidFill>
+                  <a:srgbClr val="FBB900"/>
+                </a:solidFill>
+                <a:latin typeface="Roboto"/>
+              </a:rPr>
+              <a:t>ACTIVITY</a:t>
+            </a:r>
+          </a:p>
+        </p:txBody>
+      </p:sp>
+      <p:sp>
+        <p:nvSpPr>
+          <p:cNvPr id="4" name="TextBox 3"/>
+          <p:cNvSpPr txBox="1"/>
+          <p:nvPr/>
+        </p:nvSpPr>
+        <p:spPr>
+          <a:xfrm>
+            <a:off x="2560320" y="310896"/>
+            <a:ext cx="8961120" cy="685800"/>
+          </a:xfrm>
+          <a:prstGeom prst="rect">
+            <a:avLst/>
+          </a:prstGeom>
+          <a:noFill/>
+        </p:spPr>
+        <p:txBody>
+          <a:bodyPr wrap="square" anchor="ctr" lIns="0" rIns="0" tIns="0" bIns="0">
+            <a:spAutoFit/>
+          </a:bodyPr>
+          <a:lstStyle/>
+          <a:p>
+            <a:r>
+              <a:rPr sz="2600" b="1" i="0">
+                <a:solidFill>
+                  <a:srgbClr val="FFFFFF"/>
+                </a:solidFill>
+                <a:latin typeface="Roboto"/>
+              </a:rPr>
+              <a:t>Lodge and close</a:t>
+            </a:r>
+          </a:p>
+        </p:txBody>
+      </p:sp>
+      <p:sp>
+        <p:nvSpPr>
+          <p:cNvPr id="5" name="TextBox 4"/>
+          <p:cNvSpPr txBox="1"/>
+          <p:nvPr/>
+        </p:nvSpPr>
+        <p:spPr>
+          <a:xfrm>
+            <a:off x="658368" y="1554480"/>
+            <a:ext cx="10881360" cy="4297680"/>
+          </a:xfrm>
+          <a:prstGeom prst="rect">
+            <a:avLst/>
+          </a:prstGeom>
+          <a:noFill/>
+        </p:spPr>
+        <p:txBody>
+          <a:bodyPr wrap="square" anchor="t" lIns="0" rIns="0" tIns="0" bIns="0">
+            <a:spAutoFit/>
+          </a:bodyPr>
+          <a:lstStyle/>
+          <a:p>
+            <a:pPr marL="0" indent="0">
+              <a:lnSpc>
+                <a:spcPct val="105000"/>
+              </a:lnSpc>
+              <a:spcBef>
+                <a:spcPts val="0"/>
+              </a:spcBef>
+              <a:spcAft>
+                <a:spcPts val="1000"/>
+              </a:spcAft>
+            </a:pPr>
+            <a:r>
               <a:rPr sz="1700" b="1" i="0">
                 <a:solidFill>
                   <a:srgbClr val="EDAB0C"/>
@@ -6651,7 +7252,38 @@
                 </a:solidFill>
                 <a:latin typeface="Roboto"/>
               </a:rPr>
-              <a:t>Obtain and record the final sign-off.</a:t>
+              <a:t>Workbook — tasks 42 and 43.</a:t>
+            </a:r>
+          </a:p>
+          <a:p>
+            <a:pPr marL="0" indent="0">
+              <a:lnSpc>
+                <a:spcPct val="105000"/>
+              </a:lnSpc>
+              <a:spcBef>
+                <a:spcPts val="0"/>
+              </a:spcBef>
+              <a:spcAft>
+                <a:spcPts val="1000"/>
+              </a:spcAft>
+            </a:pPr>
+            <a:r>
+              <a:rPr sz="1700" b="1" i="0">
+                <a:solidFill>
+                  <a:srgbClr val="EDAB0C"/>
+                </a:solidFill>
+                <a:latin typeface="Roboto"/>
+              </a:rPr>
+              <a:t>■  </a:t>
+            </a:r>
+            <a:r>
+              <a:rPr sz="1700" b="0" i="0">
+                <a:solidFill>
+                  <a:srgbClr val="2A2929"/>
+                </a:solidFill>
+                <a:latin typeface="Roboto"/>
+              </a:rPr>
+              <a:t>Work out the lodgement the records policy requires and do it, then ask for sign-off and record the decision.</a:t>
             </a:r>
           </a:p>
         </p:txBody>
@@ -6731,7 +7363,7 @@
                 </a:solidFill>
                 <a:latin typeface="Roboto"/>
               </a:rPr>
-              <a:t>⏱  ~15 min</a:t>
+              <a:t>⏱  ~20 min</a:t>
             </a:r>
           </a:p>
         </p:txBody>
@@ -6853,7 +7485,7 @@
                 </a:solidFill>
                 <a:latin typeface="Roboto"/>
               </a:rPr>
-              <a:t>10</a:t>
+              <a:t>13</a:t>
             </a:r>
           </a:p>
         </p:txBody>
@@ -6866,7 +7498,7 @@
 </p:sld>
 </file>
 
-<file path=ppt/slides/slide15.xml><?xml version="1.0" encoding="utf-8"?>
+<file path=ppt/slides/slide18.xml><?xml version="1.0" encoding="utf-8"?>
 <p:sld xmlns:a="http://schemas.openxmlformats.org/drawingml/2006/main" xmlns:p="http://schemas.openxmlformats.org/presentationml/2006/main" xmlns:r="http://schemas.openxmlformats.org/officeDocument/2006/relationships">
   <p:cSld>
     <p:bg>
@@ -7102,7 +7734,7 @@
                 </a:solidFill>
                 <a:latin typeface="Roboto"/>
               </a:rPr>
-              <a:t>Assemble the Solution Design in the YAT template — complete, consistent, professional English.</a:t>
+              <a:t>One point per part; prepare the questions your choices invite.</a:t>
             </a:r>
           </a:p>
         </p:txBody>
@@ -7231,7 +7863,7 @@
                 </a:solidFill>
                 <a:latin typeface="Roboto"/>
               </a:rPr>
-              <a:t>Justify every change and design choice — the requirement, the option, and why.</a:t>
+              <a:t>Present, seek feedback, respond with reasons, record everything.</a:t>
             </a:r>
           </a:p>
         </p:txBody>
@@ -7360,7 +7992,7 @@
                 </a:solidFill>
                 <a:latin typeface="Roboto"/>
               </a:rPr>
-              <a:t>Present the design + DR plan; seek and respond to feedback; answer Q&amp;A on your choices.</a:t>
+              <a:t>Lodge to policy; record the decision, conditions and all.</a:t>
             </a:r>
           </a:p>
         </p:txBody>
@@ -7373,54 +8005,8 @@
         </p:nvSpPr>
         <p:spPr>
           <a:xfrm>
-            <a:off x="640080" y="4818888"/>
-            <a:ext cx="10927080" cy="841248"/>
-          </a:xfrm>
-          <a:prstGeom prst="rect">
-            <a:avLst/>
-          </a:prstGeom>
-          <a:solidFill>
-            <a:srgbClr val="FFFFFF"/>
-          </a:solidFill>
-          <a:ln w="12700">
-            <a:solidFill>
-              <a:srgbClr val="CCCCCC"/>
-            </a:solidFill>
-          </a:ln>
-          <a:effectLst/>
-        </p:spPr>
-        <p:style>
-          <a:lnRef idx="1">
-            <a:schemeClr val="accent1"/>
-          </a:lnRef>
-          <a:fillRef idx="3">
-            <a:schemeClr val="accent1"/>
-          </a:fillRef>
-          <a:effectRef idx="2">
-            <a:schemeClr val="accent1"/>
-          </a:effectRef>
-          <a:fontRef idx="minor">
-            <a:schemeClr val="lt1"/>
-          </a:fontRef>
-        </p:style>
-        <p:txBody>
-          <a:bodyPr rtlCol="0" anchor="ctr"/>
-          <a:lstStyle/>
-          <a:p>
-            <a:pPr algn="ctr"/>
-          </a:p>
-        </p:txBody>
-      </p:sp>
-      <p:sp>
-        <p:nvSpPr>
-          <p:cNvPr id="14" name="Rectangle 13"/>
-          <p:cNvSpPr/>
-          <p:nvPr/>
-        </p:nvSpPr>
-        <p:spPr>
-          <a:xfrm>
-            <a:off x="640080" y="4818888"/>
-            <a:ext cx="109728" cy="841248"/>
+            <a:off x="0" y="6565392"/>
+            <a:ext cx="12191695" cy="38100"/>
           </a:xfrm>
           <a:prstGeom prst="rect">
             <a:avLst/>
@@ -7457,90 +8043,7 @@
       </p:sp>
       <p:sp>
         <p:nvSpPr>
-          <p:cNvPr id="15" name="TextBox 14"/>
-          <p:cNvSpPr txBox="1"/>
-          <p:nvPr/>
-        </p:nvSpPr>
-        <p:spPr>
-          <a:xfrm>
-            <a:off x="960120" y="4818888"/>
-            <a:ext cx="10424160" cy="841248"/>
-          </a:xfrm>
-          <a:prstGeom prst="rect">
-            <a:avLst/>
-          </a:prstGeom>
-          <a:noFill/>
-        </p:spPr>
-        <p:txBody>
-          <a:bodyPr wrap="square" anchor="ctr" lIns="0" rIns="0" tIns="0" bIns="0">
-            <a:spAutoFit/>
-          </a:bodyPr>
-          <a:lstStyle/>
-          <a:p>
-            <a:pPr>
-              <a:lnSpc>
-                <a:spcPct val="100000"/>
-              </a:lnSpc>
-            </a:pPr>
-            <a:r>
-              <a:rPr sz="1700" b="0" i="0">
-                <a:solidFill>
-                  <a:srgbClr val="2A2929"/>
-                </a:solidFill>
-                <a:latin typeface="Roboto"/>
-              </a:rPr>
-              <a:t>Lodge per protocol and obtain sign-off — the gate to AT2 implementation.</a:t>
-            </a:r>
-          </a:p>
-        </p:txBody>
-      </p:sp>
-      <p:sp>
-        <p:nvSpPr>
-          <p:cNvPr id="16" name="Rectangle 15"/>
-          <p:cNvSpPr/>
-          <p:nvPr/>
-        </p:nvSpPr>
-        <p:spPr>
-          <a:xfrm>
-            <a:off x="0" y="6565392"/>
-            <a:ext cx="12191695" cy="38100"/>
-          </a:xfrm>
-          <a:prstGeom prst="rect">
-            <a:avLst/>
-          </a:prstGeom>
-          <a:solidFill>
-            <a:srgbClr val="205F61"/>
-          </a:solidFill>
-          <a:ln>
-            <a:noFill/>
-          </a:ln>
-          <a:effectLst/>
-        </p:spPr>
-        <p:style>
-          <a:lnRef idx="1">
-            <a:schemeClr val="accent1"/>
-          </a:lnRef>
-          <a:fillRef idx="3">
-            <a:schemeClr val="accent1"/>
-          </a:fillRef>
-          <a:effectRef idx="2">
-            <a:schemeClr val="accent1"/>
-          </a:effectRef>
-          <a:fontRef idx="minor">
-            <a:schemeClr val="lt1"/>
-          </a:fontRef>
-        </p:style>
-        <p:txBody>
-          <a:bodyPr rtlCol="0" anchor="ctr"/>
-          <a:lstStyle/>
-          <a:p>
-            <a:pPr algn="ctr"/>
-          </a:p>
-        </p:txBody>
-      </p:sp>
-      <p:sp>
-        <p:nvSpPr>
-          <p:cNvPr id="17" name="TextBox 16"/>
+          <p:cNvPr id="14" name="TextBox 13"/>
           <p:cNvSpPr txBox="1"/>
           <p:nvPr/>
         </p:nvSpPr>
@@ -7583,7 +8086,7 @@
       </p:sp>
       <p:sp>
         <p:nvSpPr>
-          <p:cNvPr id="18" name="TextBox 17"/>
+          <p:cNvPr id="15" name="TextBox 14"/>
           <p:cNvSpPr txBox="1"/>
           <p:nvPr/>
         </p:nvSpPr>
@@ -7611,7 +8114,7 @@
                 </a:solidFill>
                 <a:latin typeface="Roboto"/>
               </a:rPr>
-              <a:t>11</a:t>
+              <a:t>14</a:t>
             </a:r>
           </a:p>
         </p:txBody>
@@ -7624,7 +8127,7 @@
 </p:sld>
 </file>
 
-<file path=ppt/slides/slide16.xml><?xml version="1.0" encoding="utf-8"?>
+<file path=ppt/slides/slide19.xml><?xml version="1.0" encoding="utf-8"?>
 <p:sld xmlns:a="http://schemas.openxmlformats.org/drawingml/2006/main" xmlns:p="http://schemas.openxmlformats.org/presentationml/2006/main" xmlns:r="http://schemas.openxmlformats.org/officeDocument/2006/relationships">
   <p:cSld>
     <p:bg>
@@ -7715,7 +8218,7 @@
                 </a:solidFill>
                 <a:latin typeface="Roboto"/>
               </a:rPr>
-              <a:t>Next: Topic 6 — AT2 build begins</a:t>
+              <a:t>AT1 is done — next, the build</a:t>
             </a:r>
           </a:p>
           <a:p>
@@ -7734,7 +8237,7 @@
                 </a:solidFill>
                 <a:latin typeface="Roboto Light"/>
               </a:rPr>
-              <a:t>AT1 is closed out: designed, documented, presented, signed off.</a:t>
+              <a:t>Designed, planned, presented, approved and lodged: the whole advisory engagement, end to end.</a:t>
             </a:r>
           </a:p>
           <a:p>
@@ -7753,7 +8256,7 @@
                 </a:solidFill>
                 <a:latin typeface="Roboto Light"/>
               </a:rPr>
-              <a:t>Next you switch from design to build — implement the web-scale foundation in the lab.</a:t>
+              <a:t>Next topic the keyboard comes out — infrastructure as code, and the AT2 build.</a:t>
             </a:r>
           </a:p>
         </p:txBody>
@@ -7911,7 +8414,7 @@
                 </a:solidFill>
                 <a:latin typeface="Roboto"/>
               </a:rPr>
-              <a:t>Topics 1–4 produced the design and the DR plan; Topic 5 turns them into approved deliverables.</a:t>
+              <a:t>The Solution Design and the Disaster Recovery Plan are written. Now the client has to approve them.</a:t>
             </a:r>
           </a:p>
           <a:p>
@@ -7942,7 +8445,7 @@
                 </a:solidFill>
                 <a:latin typeface="Roboto"/>
               </a:rPr>
-              <a:t>Two things: document and justify the Solution Design, then present both for approval.</a:t>
+              <a:t>Today: plan the walkthrough, anticipate the questions, run it, respond to the feedback, lodge, and get sign-off.</a:t>
             </a:r>
           </a:p>
           <a:p>
@@ -7973,45 +8476,14 @@
                 </a:solidFill>
                 <a:latin typeface="Roboto"/>
               </a:rPr>
-              <a:t>Approval is the gate — AT2 implementation only starts once the design is signed off.</a:t>
-            </a:r>
-          </a:p>
-          <a:p>
-            <a:pPr marL="0" indent="0">
-              <a:lnSpc>
-                <a:spcPct val="105000"/>
-              </a:lnSpc>
-              <a:spcBef>
-                <a:spcPts val="0"/>
-              </a:spcBef>
-              <a:spcAft>
-                <a:spcPts val="1000"/>
-              </a:spcAft>
-            </a:pPr>
-            <a:r>
-              <a:rPr sz="1700" b="1" i="0">
-                <a:solidFill>
-                  <a:srgbClr val="EDAB0C"/>
-                </a:solidFill>
-                <a:latin typeface="Roboto"/>
-              </a:rPr>
-              <a:t>■  </a:t>
-            </a:r>
-            <a:r>
-              <a:rPr sz="1700" b="0" i="0">
-                <a:solidFill>
-                  <a:srgbClr val="2A2929"/>
-                </a:solidFill>
-                <a:latin typeface="Roboto"/>
-              </a:rPr>
-              <a:t>No new design and no build here — assemble, present, sign off.</a:t>
+              <a:t>An engagement isn't finished when the documents are — it's finished when the client signs.</a:t>
             </a:r>
           </a:p>
         </p:txBody>
       </p:sp>
       <p:pic>
         <p:nvPicPr>
-          <p:cNvPr id="5" name="Picture 4" descr="gen-ff1b107d.png"/>
+          <p:cNvPr id="5" name="Picture 4" descr="gen-c9c1f5af.png"/>
           <p:cNvPicPr>
             <a:picLocks noChangeAspect="1"/>
           </p:cNvPicPr>
@@ -8304,7 +8776,7 @@
                 </a:solidFill>
                 <a:latin typeface="Roboto"/>
               </a:rPr>
-              <a:t>Documenting &amp; justifying the design</a:t>
+              <a:t>Preparing the walkthrough</a:t>
             </a:r>
           </a:p>
           <a:p>
@@ -8320,7 +8792,7 @@
                 </a:solidFill>
                 <a:latin typeface="Roboto Light"/>
               </a:rPr>
-              <a:t>write it down, and say why</a:t>
+              <a:t>one point per part, and the hard questions first</a:t>
             </a:r>
           </a:p>
         </p:txBody>
@@ -8502,7 +8974,7 @@
                 </a:solidFill>
                 <a:latin typeface="Roboto"/>
               </a:rPr>
-              <a:t>Documenting to a template</a:t>
+              <a:t>What an approval walkthrough is</a:t>
             </a:r>
           </a:p>
         </p:txBody>
@@ -8600,7 +9072,7 @@
                 </a:solidFill>
                 <a:latin typeface="Roboto"/>
               </a:rPr>
-              <a:t>A Solution Design is a professional document, not notes — complete, consistent, and readable by a non-author.</a:t>
+              <a:t>A walkthrough presents the design and plan to the people who must approve them, for a decision.</a:t>
             </a:r>
           </a:p>
           <a:p>
@@ -8631,7 +9103,7 @@
                 </a:solidFill>
                 <a:latin typeface="Roboto"/>
               </a:rPr>
-              <a:t>Write to the YAT template so structure and quality are predictable.</a:t>
+              <a:t>Speak to your choices and their rationale — the decisions that matter, not every line.</a:t>
             </a:r>
           </a:p>
           <a:p>
@@ -8662,7 +9134,7 @@
                 </a:solidFill>
                 <a:latin typeface="Roboto"/>
               </a:rPr>
-              <a:t>Plain professional English: precise, no jargon for its own sake.</a:t>
+              <a:t>Approval is a conversation: they will probe, you will respond.</a:t>
             </a:r>
           </a:p>
         </p:txBody>
@@ -8844,7 +9316,7 @@
                 </a:solidFill>
                 <a:latin typeface="Roboto"/>
               </a:rPr>
-              <a:t>Assemble the Solution Design</a:t>
+              <a:t>Plan the order, and the one point per part</a:t>
             </a:r>
           </a:p>
         </p:txBody>
@@ -8942,7 +9414,7 @@
                 </a:solidFill>
                 <a:latin typeface="Roboto"/>
               </a:rPr>
-              <a:t>Bring together the web-scale architecture (Topic 1) and the microservice design (Topic 2) into one document.</a:t>
+              <a:t>Decide the order you take the client through the two documents.</a:t>
             </a:r>
           </a:p>
           <a:p>
@@ -8973,7 +9445,7 @@
                 </a:solidFill>
                 <a:latin typeface="Roboto"/>
               </a:rPr>
-              <a:t>Each section maps to a requirement — a reader can trace design back to need.</a:t>
+              <a:t>For each part, write the one point they must understand — if they remember one thing per section, which thing?</a:t>
             </a:r>
           </a:p>
           <a:p>
@@ -9004,7 +9476,7 @@
                 </a:solidFill>
                 <a:latin typeface="Roboto"/>
               </a:rPr>
-              <a:t>Internal consistency: the diagrams, tables and prose agree.</a:t>
+              <a:t>Time it against the slot you have; running out of time is the most common way this goes wrong.</a:t>
             </a:r>
           </a:p>
         </p:txBody>
@@ -9186,7 +9658,7 @@
                 </a:solidFill>
                 <a:latin typeface="Roboto"/>
               </a:rPr>
-              <a:t>Justify the changes &amp; the design</a:t>
+              <a:t>Anticipate the questions</a:t>
             </a:r>
           </a:p>
         </p:txBody>
@@ -9284,7 +9756,7 @@
                 </a:solidFill>
                 <a:latin typeface="Roboto"/>
               </a:rPr>
-              <a:t>Document and justify the architecture changes (web-scale) and the microservice architecture design.</a:t>
+              <a:t>Write the questions you would ask if you were the client, and your answer to each.</a:t>
             </a:r>
           </a:p>
           <a:p>
@@ -9315,7 +9787,7 @@
                 </a:solidFill>
                 <a:latin typeface="Roboto"/>
               </a:rPr>
-              <a:t>Justification = the requirement met, the option chosen, and why over the alternatives.</a:t>
+              <a:t>The ones worth preparing are where you made a choice someone could challenge.</a:t>
             </a:r>
           </a:p>
           <a:p>
@@ -9346,7 +9818,7 @@
                 </a:solidFill>
                 <a:latin typeface="Roboto"/>
               </a:rPr>
-              <a:t>Unjustified design is an opinion; justified design is defensible under Q&amp;A.</a:t>
+              <a:t>If you justified the choice in the document, the answer is already written — find it.</a:t>
             </a:r>
           </a:p>
         </p:txBody>
@@ -9625,7 +10097,7 @@
                 </a:solidFill>
                 <a:latin typeface="Roboto"/>
               </a:rPr>
-              <a:t>Assemble &amp; justify</a:t>
+              <a:t>Plan and prepare</a:t>
             </a:r>
           </a:p>
         </p:txBody>
@@ -9679,7 +10151,7 @@
                 </a:solidFill>
                 <a:latin typeface="Roboto"/>
               </a:rPr>
-              <a:t>For the practice scenario, assemble the Solution Design in the YAT template.</a:t>
+              <a:t>Workbook — tasks 38 and 39.</a:t>
             </a:r>
           </a:p>
           <a:p>
@@ -9710,7 +10182,7 @@
                 </a:solidFill>
                 <a:latin typeface="Roboto"/>
               </a:rPr>
-              <a:t>Document and justify the architecture changes and the microservice design.</a:t>
+              <a:t>Plan the walkthrough order with the one point per part, then write the questions you'd ask in the client's place and your answers.</a:t>
             </a:r>
           </a:p>
         </p:txBody>
@@ -9790,7 +10262,7 @@
                 </a:solidFill>
                 <a:latin typeface="Roboto"/>
               </a:rPr>
-              <a:t>⏱  ~30 min</a:t>
+              <a:t>⏱  ~25 min</a:t>
             </a:r>
           </a:p>
         </p:txBody>
@@ -9931,7 +10403,7 @@
     <p:bg>
       <p:bgPr>
         <a:solidFill>
-          <a:srgbClr val="FFFFFF"/>
+          <a:srgbClr val="F9F9F9"/>
         </a:solidFill>
         <a:effectLst/>
       </p:bgPr>
@@ -9945,20 +10417,70 @@
       <p:grpSpPr/>
       <p:sp>
         <p:nvSpPr>
-          <p:cNvPr id="2" name="Rectangle 1"/>
+          <p:cNvPr id="2" name="TextBox 1"/>
+          <p:cNvSpPr txBox="1"/>
+          <p:nvPr/>
+        </p:nvSpPr>
+        <p:spPr>
+          <a:xfrm>
+            <a:off x="640080" y="548640"/>
+            <a:ext cx="10881360" cy="1097280"/>
+          </a:xfrm>
+          <a:prstGeom prst="rect">
+            <a:avLst/>
+          </a:prstGeom>
+          <a:noFill/>
+        </p:spPr>
+        <p:txBody>
+          <a:bodyPr wrap="square" anchor="t" lIns="0" rIns="0" tIns="0" bIns="0">
+            <a:spAutoFit/>
+          </a:bodyPr>
+          <a:lstStyle/>
+          <a:p>
+            <a:r>
+              <a:rPr sz="3200" b="1" i="0">
+                <a:solidFill>
+                  <a:srgbClr val="2A2929"/>
+                </a:solidFill>
+                <a:latin typeface="Roboto"/>
+              </a:rPr>
+              <a:t>Key takeaways</a:t>
+            </a:r>
+          </a:p>
+          <a:p>
+            <a:pPr>
+              <a:spcBef>
+                <a:spcPts val="200"/>
+              </a:spcBef>
+            </a:pPr>
+            <a:r>
+              <a:rPr sz="1800" b="1" i="0">
+                <a:solidFill>
+                  <a:srgbClr val="92268F"/>
+                </a:solidFill>
+                <a:latin typeface="Roboto"/>
+              </a:rPr>
+              <a:t>Section 1 · Preparation</a:t>
+            </a:r>
+          </a:p>
+        </p:txBody>
+      </p:sp>
+      <p:sp>
+        <p:nvSpPr>
+          <p:cNvPr id="3" name="Rectangle 2"/>
           <p:cNvSpPr/>
           <p:nvPr/>
         </p:nvSpPr>
         <p:spPr>
           <a:xfrm>
-            <a:off x="0" y="0"/>
-            <a:ext cx="3931920" cy="6858000"/>
+            <a:off x="658368" y="1600200"/>
+            <a:ext cx="1463040" cy="50800"/>
           </a:xfrm>
           <a:prstGeom prst="rect">
             <a:avLst/>
           </a:prstGeom>
           <a:solidFill>
-            <a:srgbClr val="27B5CE"/>
+            <a:srgbClr val="92268F"/>
           </a:solidFill>
           <a:ln>
             <a:noFill/>
@@ -9989,101 +10511,47 @@
       </p:sp>
       <p:sp>
         <p:nvSpPr>
-          <p:cNvPr id="3" name="TextBox 2"/>
-          <p:cNvSpPr txBox="1"/>
-          <p:nvPr/>
-        </p:nvSpPr>
-        <p:spPr>
-          <a:xfrm>
-            <a:off x="365760" y="2103120"/>
-            <a:ext cx="3291840" cy="2194560"/>
-          </a:xfrm>
-          <a:prstGeom prst="rect">
-            <a:avLst/>
-          </a:prstGeom>
-          <a:noFill/>
-        </p:spPr>
-        <p:txBody>
-          <a:bodyPr wrap="square" anchor="t" lIns="0" rIns="0" tIns="0" bIns="0">
-            <a:spAutoFit/>
-          </a:bodyPr>
-          <a:lstStyle/>
-          <a:p>
-            <a:r>
-              <a:rPr sz="13000" b="1" i="0">
-                <a:solidFill>
-                  <a:srgbClr val="FFFFFF"/>
-                </a:solidFill>
-                <a:latin typeface="Roboto"/>
-              </a:rPr>
-              <a:t>02</a:t>
-            </a:r>
-          </a:p>
-        </p:txBody>
-      </p:sp>
-      <p:sp>
-        <p:nvSpPr>
-          <p:cNvPr id="4" name="TextBox 3"/>
-          <p:cNvSpPr txBox="1"/>
-          <p:nvPr/>
-        </p:nvSpPr>
-        <p:spPr>
-          <a:xfrm>
-            <a:off x="4480560" y="2468880"/>
-            <a:ext cx="7132320" cy="2194560"/>
-          </a:xfrm>
-          <a:prstGeom prst="rect">
-            <a:avLst/>
-          </a:prstGeom>
-          <a:noFill/>
-        </p:spPr>
-        <p:txBody>
-          <a:bodyPr wrap="square" anchor="t" lIns="0" rIns="0" tIns="0" bIns="0">
-            <a:spAutoFit/>
-          </a:bodyPr>
-          <a:lstStyle/>
-          <a:p>
-            <a:r>
-              <a:rPr sz="1600" b="1" i="0">
-                <a:solidFill>
-                  <a:srgbClr val="27B5CE"/>
-                </a:solidFill>
-                <a:latin typeface="Roboto"/>
-              </a:rPr>
-              <a:t>SECTION</a:t>
-            </a:r>
-          </a:p>
-          <a:p>
-            <a:pPr>
-              <a:spcBef>
-                <a:spcPts val="600"/>
-              </a:spcBef>
-            </a:pPr>
-            <a:r>
-              <a:rPr sz="3800" b="1" i="0">
-                <a:solidFill>
-                  <a:srgbClr val="2A2929"/>
-                </a:solidFill>
-                <a:latin typeface="Roboto"/>
-              </a:rPr>
-              <a:t>Presenting for approval</a:t>
-            </a:r>
-          </a:p>
-          <a:p>
-            <a:pPr>
-              <a:spcBef>
-                <a:spcPts val="1000"/>
-              </a:spcBef>
-            </a:pPr>
-            <a:r>
-              <a:rPr sz="2000" b="0" i="1">
-                <a:solidFill>
-                  <a:srgbClr val="484848"/>
-                </a:solidFill>
-                <a:latin typeface="Roboto Light"/>
-              </a:rPr>
-              <a:t>walk them through it, and listen</a:t>
-            </a:r>
+          <p:cNvPr id="4" name="Rectangle 3"/>
+          <p:cNvSpPr/>
+          <p:nvPr/>
+        </p:nvSpPr>
+        <p:spPr>
+          <a:xfrm>
+            <a:off x="640080" y="1965960"/>
+            <a:ext cx="10927080" cy="841248"/>
+          </a:xfrm>
+          <a:prstGeom prst="rect">
+            <a:avLst/>
+          </a:prstGeom>
+          <a:solidFill>
+            <a:srgbClr val="FFFFFF"/>
+          </a:solidFill>
+          <a:ln w="12700">
+            <a:solidFill>
+              <a:srgbClr val="CCCCCC"/>
+            </a:solidFill>
+          </a:ln>
+          <a:effectLst/>
+        </p:spPr>
+        <p:style>
+          <a:lnRef idx="1">
+            <a:schemeClr val="accent1"/>
+          </a:lnRef>
+          <a:fillRef idx="3">
+            <a:schemeClr val="accent1"/>
+          </a:fillRef>
+          <a:effectRef idx="2">
+            <a:schemeClr val="accent1"/>
+          </a:effectRef>
+          <a:fontRef idx="minor">
+            <a:schemeClr val="lt1"/>
+          </a:fontRef>
+        </p:style>
+        <p:txBody>
+          <a:bodyPr rtlCol="0" anchor="ctr"/>
+          <a:lstStyle/>
+          <a:p>
+            <a:pPr algn="ctr"/>
           </a:p>
         </p:txBody>
       </p:sp>
@@ -10095,14 +10563,14 @@
         </p:nvSpPr>
         <p:spPr>
           <a:xfrm>
-            <a:off x="0" y="6565392"/>
-            <a:ext cx="12191695" cy="38100"/>
+            <a:off x="640080" y="1965960"/>
+            <a:ext cx="109728" cy="841248"/>
           </a:xfrm>
           <a:prstGeom prst="rect">
             <a:avLst/>
           </a:prstGeom>
           <a:solidFill>
-            <a:srgbClr val="27B5CE"/>
+            <a:srgbClr val="92268F"/>
           </a:solidFill>
           <a:ln>
             <a:noFill/>
@@ -10139,6 +10607,218 @@
         </p:nvSpPr>
         <p:spPr>
           <a:xfrm>
+            <a:off x="960120" y="1965960"/>
+            <a:ext cx="10424160" cy="841248"/>
+          </a:xfrm>
+          <a:prstGeom prst="rect">
+            <a:avLst/>
+          </a:prstGeom>
+          <a:noFill/>
+        </p:spPr>
+        <p:txBody>
+          <a:bodyPr wrap="square" anchor="ctr" lIns="0" rIns="0" tIns="0" bIns="0">
+            <a:spAutoFit/>
+          </a:bodyPr>
+          <a:lstStyle/>
+          <a:p>
+            <a:pPr>
+              <a:lnSpc>
+                <a:spcPct val="100000"/>
+              </a:lnSpc>
+            </a:pPr>
+            <a:r>
+              <a:rPr sz="1700" b="0" i="0">
+                <a:solidFill>
+                  <a:srgbClr val="2A2929"/>
+                </a:solidFill>
+                <a:latin typeface="Roboto"/>
+              </a:rPr>
+              <a:t>Order, one point per part, timed to the slot.</a:t>
+            </a:r>
+          </a:p>
+        </p:txBody>
+      </p:sp>
+      <p:sp>
+        <p:nvSpPr>
+          <p:cNvPr id="7" name="Rectangle 6"/>
+          <p:cNvSpPr/>
+          <p:nvPr/>
+        </p:nvSpPr>
+        <p:spPr>
+          <a:xfrm>
+            <a:off x="640080" y="2916936"/>
+            <a:ext cx="10927080" cy="841248"/>
+          </a:xfrm>
+          <a:prstGeom prst="rect">
+            <a:avLst/>
+          </a:prstGeom>
+          <a:solidFill>
+            <a:srgbClr val="FFFFFF"/>
+          </a:solidFill>
+          <a:ln w="12700">
+            <a:solidFill>
+              <a:srgbClr val="CCCCCC"/>
+            </a:solidFill>
+          </a:ln>
+          <a:effectLst/>
+        </p:spPr>
+        <p:style>
+          <a:lnRef idx="1">
+            <a:schemeClr val="accent1"/>
+          </a:lnRef>
+          <a:fillRef idx="3">
+            <a:schemeClr val="accent1"/>
+          </a:fillRef>
+          <a:effectRef idx="2">
+            <a:schemeClr val="accent1"/>
+          </a:effectRef>
+          <a:fontRef idx="minor">
+            <a:schemeClr val="lt1"/>
+          </a:fontRef>
+        </p:style>
+        <p:txBody>
+          <a:bodyPr rtlCol="0" anchor="ctr"/>
+          <a:lstStyle/>
+          <a:p>
+            <a:pPr algn="ctr"/>
+          </a:p>
+        </p:txBody>
+      </p:sp>
+      <p:sp>
+        <p:nvSpPr>
+          <p:cNvPr id="8" name="Rectangle 7"/>
+          <p:cNvSpPr/>
+          <p:nvPr/>
+        </p:nvSpPr>
+        <p:spPr>
+          <a:xfrm>
+            <a:off x="640080" y="2916936"/>
+            <a:ext cx="109728" cy="841248"/>
+          </a:xfrm>
+          <a:prstGeom prst="rect">
+            <a:avLst/>
+          </a:prstGeom>
+          <a:solidFill>
+            <a:srgbClr val="92268F"/>
+          </a:solidFill>
+          <a:ln>
+            <a:noFill/>
+          </a:ln>
+          <a:effectLst/>
+        </p:spPr>
+        <p:style>
+          <a:lnRef idx="1">
+            <a:schemeClr val="accent1"/>
+          </a:lnRef>
+          <a:fillRef idx="3">
+            <a:schemeClr val="accent1"/>
+          </a:fillRef>
+          <a:effectRef idx="2">
+            <a:schemeClr val="accent1"/>
+          </a:effectRef>
+          <a:fontRef idx="minor">
+            <a:schemeClr val="lt1"/>
+          </a:fontRef>
+        </p:style>
+        <p:txBody>
+          <a:bodyPr rtlCol="0" anchor="ctr"/>
+          <a:lstStyle/>
+          <a:p>
+            <a:pPr algn="ctr"/>
+          </a:p>
+        </p:txBody>
+      </p:sp>
+      <p:sp>
+        <p:nvSpPr>
+          <p:cNvPr id="9" name="TextBox 8"/>
+          <p:cNvSpPr txBox="1"/>
+          <p:nvPr/>
+        </p:nvSpPr>
+        <p:spPr>
+          <a:xfrm>
+            <a:off x="960120" y="2916936"/>
+            <a:ext cx="10424160" cy="841248"/>
+          </a:xfrm>
+          <a:prstGeom prst="rect">
+            <a:avLst/>
+          </a:prstGeom>
+          <a:noFill/>
+        </p:spPr>
+        <p:txBody>
+          <a:bodyPr wrap="square" anchor="ctr" lIns="0" rIns="0" tIns="0" bIns="0">
+            <a:spAutoFit/>
+          </a:bodyPr>
+          <a:lstStyle/>
+          <a:p>
+            <a:pPr>
+              <a:lnSpc>
+                <a:spcPct val="100000"/>
+              </a:lnSpc>
+            </a:pPr>
+            <a:r>
+              <a:rPr sz="1700" b="0" i="0">
+                <a:solidFill>
+                  <a:srgbClr val="2A2929"/>
+                </a:solidFill>
+                <a:latin typeface="Roboto"/>
+              </a:rPr>
+              <a:t>Prepare the questions your own choices invite.</a:t>
+            </a:r>
+          </a:p>
+        </p:txBody>
+      </p:sp>
+      <p:sp>
+        <p:nvSpPr>
+          <p:cNvPr id="10" name="Rectangle 9"/>
+          <p:cNvSpPr/>
+          <p:nvPr/>
+        </p:nvSpPr>
+        <p:spPr>
+          <a:xfrm>
+            <a:off x="0" y="6565392"/>
+            <a:ext cx="12191695" cy="38100"/>
+          </a:xfrm>
+          <a:prstGeom prst="rect">
+            <a:avLst/>
+          </a:prstGeom>
+          <a:solidFill>
+            <a:srgbClr val="92268F"/>
+          </a:solidFill>
+          <a:ln>
+            <a:noFill/>
+          </a:ln>
+          <a:effectLst/>
+        </p:spPr>
+        <p:style>
+          <a:lnRef idx="1">
+            <a:schemeClr val="accent1"/>
+          </a:lnRef>
+          <a:fillRef idx="3">
+            <a:schemeClr val="accent1"/>
+          </a:fillRef>
+          <a:effectRef idx="2">
+            <a:schemeClr val="accent1"/>
+          </a:effectRef>
+          <a:fontRef idx="minor">
+            <a:schemeClr val="lt1"/>
+          </a:fontRef>
+        </p:style>
+        <p:txBody>
+          <a:bodyPr rtlCol="0" anchor="ctr"/>
+          <a:lstStyle/>
+          <a:p>
+            <a:pPr algn="ctr"/>
+          </a:p>
+        </p:txBody>
+      </p:sp>
+      <p:sp>
+        <p:nvSpPr>
+          <p:cNvPr id="11" name="TextBox 10"/>
+          <p:cNvSpPr txBox="1"/>
+          <p:nvPr/>
+        </p:nvSpPr>
+        <p:spPr>
+          <a:xfrm>
             <a:off x="502920" y="6400800"/>
             <a:ext cx="5486400" cy="320040"/>
           </a:xfrm>
@@ -10176,7 +10856,7 @@
       </p:sp>
       <p:sp>
         <p:nvSpPr>
-          <p:cNvPr id="7" name="TextBox 6"/>
+          <p:cNvPr id="12" name="TextBox 11"/>
           <p:cNvSpPr txBox="1"/>
           <p:nvPr/>
         </p:nvSpPr>
@@ -10204,7 +10884,7 @@
                 </a:solidFill>
                 <a:latin typeface="Roboto"/>
               </a:rPr>
-              <a:t/>
+              <a:t>6</a:t>
             </a:r>
           </a:p>
         </p:txBody>
@@ -10237,48 +10917,14 @@
       <p:grpSpPr/>
       <p:sp>
         <p:nvSpPr>
-          <p:cNvPr id="2" name="TextBox 1"/>
-          <p:cNvSpPr txBox="1"/>
-          <p:nvPr/>
-        </p:nvSpPr>
-        <p:spPr>
-          <a:xfrm>
-            <a:off x="640080" y="457200"/>
-            <a:ext cx="10881360" cy="960120"/>
-          </a:xfrm>
-          <a:prstGeom prst="rect">
-            <a:avLst/>
-          </a:prstGeom>
-          <a:noFill/>
-        </p:spPr>
-        <p:txBody>
-          <a:bodyPr wrap="square" anchor="t" lIns="0" rIns="0" tIns="0" bIns="0">
-            <a:spAutoFit/>
-          </a:bodyPr>
-          <a:lstStyle/>
-          <a:p>
-            <a:r>
-              <a:rPr sz="2800" b="1" i="0">
-                <a:solidFill>
-                  <a:srgbClr val="2A2929"/>
-                </a:solidFill>
-                <a:latin typeface="Roboto"/>
-              </a:rPr>
-              <a:t>The approval walkthrough</a:t>
-            </a:r>
-          </a:p>
-        </p:txBody>
-      </p:sp>
-      <p:sp>
-        <p:nvSpPr>
-          <p:cNvPr id="3" name="Rectangle 2"/>
+          <p:cNvPr id="2" name="Rectangle 1"/>
           <p:cNvSpPr/>
           <p:nvPr/>
         </p:nvSpPr>
         <p:spPr>
           <a:xfrm>
-            <a:off x="658368" y="1371600"/>
-            <a:ext cx="1463040" cy="50800"/>
+            <a:off x="0" y="0"/>
+            <a:ext cx="3931920" cy="6858000"/>
           </a:xfrm>
           <a:prstGeom prst="rect">
             <a:avLst/>
@@ -10315,14 +10961,48 @@
       </p:sp>
       <p:sp>
         <p:nvSpPr>
+          <p:cNvPr id="3" name="TextBox 2"/>
+          <p:cNvSpPr txBox="1"/>
+          <p:nvPr/>
+        </p:nvSpPr>
+        <p:spPr>
+          <a:xfrm>
+            <a:off x="365760" y="2103120"/>
+            <a:ext cx="3291840" cy="2194560"/>
+          </a:xfrm>
+          <a:prstGeom prst="rect">
+            <a:avLst/>
+          </a:prstGeom>
+          <a:noFill/>
+        </p:spPr>
+        <p:txBody>
+          <a:bodyPr wrap="square" anchor="t" lIns="0" rIns="0" tIns="0" bIns="0">
+            <a:spAutoFit/>
+          </a:bodyPr>
+          <a:lstStyle/>
+          <a:p>
+            <a:r>
+              <a:rPr sz="13000" b="1" i="0">
+                <a:solidFill>
+                  <a:srgbClr val="FFFFFF"/>
+                </a:solidFill>
+                <a:latin typeface="Roboto"/>
+              </a:rPr>
+              <a:t>02</a:t>
+            </a:r>
+          </a:p>
+        </p:txBody>
+      </p:sp>
+      <p:sp>
+        <p:nvSpPr>
           <p:cNvPr id="4" name="TextBox 3"/>
           <p:cNvSpPr txBox="1"/>
           <p:nvPr/>
         </p:nvSpPr>
         <p:spPr>
           <a:xfrm>
-            <a:off x="658368" y="1691640"/>
-            <a:ext cx="10881360" cy="4480560"/>
+            <a:off x="4480560" y="2468880"/>
+            <a:ext cx="7132320" cy="2194560"/>
           </a:xfrm>
           <a:prstGeom prst="rect">
             <a:avLst/>
@@ -10330,101 +11010,51 @@
           <a:noFill/>
         </p:spPr>
         <p:txBody>
-          <a:bodyPr wrap="square" anchor="ctr" lIns="0" rIns="0" tIns="0" bIns="0">
+          <a:bodyPr wrap="square" anchor="t" lIns="0" rIns="0" tIns="0" bIns="0">
             <a:spAutoFit/>
           </a:bodyPr>
           <a:lstStyle/>
           <a:p>
-            <a:pPr marL="0" indent="0">
-              <a:lnSpc>
-                <a:spcPct val="105000"/>
-              </a:lnSpc>
+            <a:r>
+              <a:rPr sz="1600" b="1" i="0">
+                <a:solidFill>
+                  <a:srgbClr val="27B5CE"/>
+                </a:solidFill>
+                <a:latin typeface="Roboto"/>
+              </a:rPr>
+              <a:t>SECTION</a:t>
+            </a:r>
+          </a:p>
+          <a:p>
+            <a:pPr>
               <a:spcBef>
-                <a:spcPts val="0"/>
+                <a:spcPts val="600"/>
               </a:spcBef>
-              <a:spcAft>
+            </a:pPr>
+            <a:r>
+              <a:rPr sz="3800" b="1" i="0">
+                <a:solidFill>
+                  <a:srgbClr val="2A2929"/>
+                </a:solidFill>
+                <a:latin typeface="Roboto"/>
+              </a:rPr>
+              <a:t>The walkthrough, and the feedback</a:t>
+            </a:r>
+          </a:p>
+          <a:p>
+            <a:pPr>
+              <a:spcBef>
                 <a:spcPts val="1000"/>
-              </a:spcAft>
+              </a:spcBef>
             </a:pPr>
             <a:r>
-              <a:rPr sz="2400" b="1" i="0">
-                <a:solidFill>
-                  <a:srgbClr val="EDAB0C"/>
-                </a:solidFill>
-                <a:latin typeface="Roboto"/>
-              </a:rPr>
-              <a:t>■  </a:t>
-            </a:r>
-            <a:r>
-              <a:rPr sz="2400" b="0" i="0">
-                <a:solidFill>
-                  <a:srgbClr val="2A2929"/>
-                </a:solidFill>
-                <a:latin typeface="Roboto"/>
-              </a:rPr>
-              <a:t>A walkthrough presents the design + DR plan to the required personnel for a decision.</a:t>
-            </a:r>
-          </a:p>
-          <a:p>
-            <a:pPr marL="0" indent="0">
-              <a:lnSpc>
-                <a:spcPct val="105000"/>
-              </a:lnSpc>
-              <a:spcBef>
-                <a:spcPts val="0"/>
-              </a:spcBef>
-              <a:spcAft>
-                <a:spcPts val="1000"/>
-              </a:spcAft>
-            </a:pPr>
-            <a:r>
-              <a:rPr sz="2400" b="1" i="0">
-                <a:solidFill>
-                  <a:srgbClr val="EDAB0C"/>
-                </a:solidFill>
-                <a:latin typeface="Roboto"/>
-              </a:rPr>
-              <a:t>■  </a:t>
-            </a:r>
-            <a:r>
-              <a:rPr sz="2400" b="0" i="0">
-                <a:solidFill>
-                  <a:srgbClr val="2A2929"/>
-                </a:solidFill>
-                <a:latin typeface="Roboto"/>
-              </a:rPr>
-              <a:t>Speak to your choices and their rationale — not every line, the decisions that matter.</a:t>
-            </a:r>
-          </a:p>
-          <a:p>
-            <a:pPr marL="0" indent="0">
-              <a:lnSpc>
-                <a:spcPct val="105000"/>
-              </a:lnSpc>
-              <a:spcBef>
-                <a:spcPts val="0"/>
-              </a:spcBef>
-              <a:spcAft>
-                <a:spcPts val="1000"/>
-              </a:spcAft>
-            </a:pPr>
-            <a:r>
-              <a:rPr sz="2400" b="1" i="0">
-                <a:solidFill>
-                  <a:srgbClr val="EDAB0C"/>
-                </a:solidFill>
-                <a:latin typeface="Roboto"/>
-              </a:rPr>
-              <a:t>■  </a:t>
-            </a:r>
-            <a:r>
-              <a:rPr sz="2400" b="0" i="0">
-                <a:solidFill>
-                  <a:srgbClr val="2A2929"/>
-                </a:solidFill>
-                <a:latin typeface="Roboto"/>
-              </a:rPr>
-              <a:t>Approval is a conversation: they will probe, you will respond.</a:t>
+              <a:rPr sz="2000" b="0" i="1">
+                <a:solidFill>
+                  <a:srgbClr val="484848"/>
+                </a:solidFill>
+                <a:latin typeface="Roboto Light"/>
+              </a:rPr>
+              <a:t>present, listen, respond</a:t>
             </a:r>
           </a:p>
         </p:txBody>
@@ -10546,7 +11176,7 @@
                 </a:solidFill>
                 <a:latin typeface="Roboto"/>
               </a:rPr>
-              <a:t>6</a:t>
+              <a:t/>
             </a:r>
           </a:p>
         </p:txBody>

</xml_diff>